<commit_message>
Destedeki bütün çizgileri kaldır
Geriye bıraktığım üç yapısal çizgi de fazlaymış. Artık destede hiç
çizgi yok: çözüm tablosunun başlık altı, değer zincirinin ekseni ve
dört sütunu taşıyan çizgi kalktı; 04'teki kutu kenarlıkları dolguya
döndü; bölüm etiketlerinin solundaki kısa çizgi de gitti (on iki
slaytta tekrarlandığı için desteye çizgi hissi veren şeylerin başında
geliyordu).

Yerlerine geçenler çizgi değil yüzey ve tipografi: tablo başlığı ince
bir zemin bandının üstünde duruyor, 04'ün kutuları --border-soft
dolgulu, 07'nin adımlarını büyük monospace numaralar sıralıyor.
Bölüm etiketini ayıran şey artık yalnızca yüz, renk ve harf aralığı.

Kontrol: pptx içinde prstGeom prst="line" sayısı sıfır.

Co-Authored-By: Claude Opus 5 <noreply@anthropic.com>
Claude-Session: https://claude.ai/code/session_01WXCdRgW1YBZpNXmHm1YSp8
</commit_message>
<xml_diff>
--- a/sunum/CPeak-Consultancy-Company-Overview.pptx
+++ b/sunum/CPeak-Consultancy-Company-Overview.pptx
@@ -1904,36 +1904,13 @@
       </p:pic>
       <p:sp>
         <p:nvSpPr>
-          <p:cNvPr id="4" name="Shape 0"/>
-          <p:cNvSpPr/>
-          <p:nvPr/>
-        </p:nvSpPr>
-        <p:spPr>
-          <a:xfrm>
-            <a:off x="777240" y="2592324"/>
-            <a:ext cx="237744" cy="0"/>
-          </a:xfrm>
-          <a:prstGeom prst="line">
-            <a:avLst/>
-          </a:prstGeom>
-          <a:noFill/>
-          <a:ln w="12700">
-            <a:solidFill>
-              <a:srgbClr val="F5DCA4"/>
-            </a:solidFill>
-            <a:prstDash val="solid"/>
-          </a:ln>
-        </p:spPr>
-      </p:sp>
-      <p:sp>
-        <p:nvSpPr>
-          <p:cNvPr id="5" name="Text 1"/>
-          <p:cNvSpPr txBox="1"/>
-          <p:nvPr/>
-        </p:nvSpPr>
-        <p:spPr>
-          <a:xfrm>
-            <a:off x="1106424" y="2473452"/>
+          <p:cNvPr id="4" name="Text 0"/>
+          <p:cNvSpPr txBox="1"/>
+          <p:nvPr/>
+        </p:nvSpPr>
+        <p:spPr>
+          <a:xfrm>
+            <a:off x="777240" y="2473452"/>
             <a:ext cx="5486400" cy="237744"/>
           </a:xfrm>
           <a:prstGeom prst="rect">
@@ -1966,7 +1943,7 @@
       </p:sp>
       <p:sp>
         <p:nvSpPr>
-          <p:cNvPr id="6" name="Text 2"/>
+          <p:cNvPr id="5" name="Text 1"/>
           <p:cNvSpPr txBox="1"/>
           <p:nvPr/>
         </p:nvSpPr>
@@ -2048,7 +2025,7 @@
       </p:sp>
       <p:sp>
         <p:nvSpPr>
-          <p:cNvPr id="7" name="Text 3"/>
+          <p:cNvPr id="6" name="Text 2"/>
           <p:cNvSpPr txBox="1"/>
           <p:nvPr/>
         </p:nvSpPr>
@@ -2090,7 +2067,7 @@
       </p:sp>
       <p:sp>
         <p:nvSpPr>
-          <p:cNvPr id="8" name="Text 4"/>
+          <p:cNvPr id="7" name="Text 3"/>
           <p:cNvSpPr txBox="1"/>
           <p:nvPr/>
         </p:nvSpPr>
@@ -2161,36 +2138,13 @@
       </p:grpSpPr>
       <p:sp>
         <p:nvSpPr>
-          <p:cNvPr id="2" name="Shape 0"/>
-          <p:cNvSpPr/>
-          <p:nvPr/>
-        </p:nvSpPr>
-        <p:spPr>
-          <a:xfrm>
-            <a:off x="777240" y="580644"/>
-            <a:ext cx="237744" cy="0"/>
-          </a:xfrm>
-          <a:prstGeom prst="line">
-            <a:avLst/>
-          </a:prstGeom>
-          <a:noFill/>
-          <a:ln w="12700">
-            <a:solidFill>
-              <a:srgbClr val="11676A"/>
-            </a:solidFill>
-            <a:prstDash val="solid"/>
-          </a:ln>
-        </p:spPr>
-      </p:sp>
-      <p:sp>
-        <p:nvSpPr>
-          <p:cNvPr id="3" name="Text 1"/>
-          <p:cNvSpPr txBox="1"/>
-          <p:nvPr/>
-        </p:nvSpPr>
-        <p:spPr>
-          <a:xfrm>
-            <a:off x="1106424" y="461772"/>
+          <p:cNvPr id="2" name="Text 0"/>
+          <p:cNvSpPr txBox="1"/>
+          <p:nvPr/>
+        </p:nvSpPr>
+        <p:spPr>
+          <a:xfrm>
+            <a:off x="777240" y="461772"/>
             <a:ext cx="5486400" cy="237744"/>
           </a:xfrm>
           <a:prstGeom prst="rect">
@@ -2223,7 +2177,7 @@
       </p:sp>
       <p:sp>
         <p:nvSpPr>
-          <p:cNvPr id="4" name="Text 2"/>
+          <p:cNvPr id="3" name="Text 1"/>
           <p:cNvSpPr txBox="1"/>
           <p:nvPr/>
         </p:nvSpPr>
@@ -2265,7 +2219,7 @@
       </p:sp>
       <p:sp>
         <p:nvSpPr>
-          <p:cNvPr id="5" name="Text 3"/>
+          <p:cNvPr id="4" name="Text 2"/>
           <p:cNvSpPr txBox="1"/>
           <p:nvPr/>
         </p:nvSpPr>
@@ -2307,7 +2261,7 @@
       </p:sp>
       <p:sp>
         <p:nvSpPr>
-          <p:cNvPr id="6" name="Text 4"/>
+          <p:cNvPr id="5" name="Text 3"/>
           <p:cNvSpPr txBox="1"/>
           <p:nvPr/>
         </p:nvSpPr>
@@ -2346,7 +2300,7 @@
       </p:sp>
       <p:sp>
         <p:nvSpPr>
-          <p:cNvPr id="7" name="Shape 5"/>
+          <p:cNvPr id="6" name="Shape 4"/>
           <p:cNvSpPr/>
           <p:nvPr/>
         </p:nvSpPr>
@@ -2366,7 +2320,7 @@
       </p:sp>
       <p:sp>
         <p:nvSpPr>
-          <p:cNvPr id="8" name="Text 6"/>
+          <p:cNvPr id="7" name="Text 5"/>
           <p:cNvSpPr txBox="1"/>
           <p:nvPr/>
         </p:nvSpPr>
@@ -2405,7 +2359,7 @@
       </p:sp>
       <p:sp>
         <p:nvSpPr>
-          <p:cNvPr id="9" name="Text 7"/>
+          <p:cNvPr id="8" name="Text 6"/>
           <p:cNvSpPr txBox="1"/>
           <p:nvPr/>
         </p:nvSpPr>
@@ -2444,7 +2398,7 @@
       </p:sp>
       <p:sp>
         <p:nvSpPr>
-          <p:cNvPr id="10" name="Text 8"/>
+          <p:cNvPr id="9" name="Text 7"/>
           <p:cNvSpPr txBox="1"/>
           <p:nvPr/>
         </p:nvSpPr>
@@ -2483,7 +2437,7 @@
       </p:sp>
       <p:sp>
         <p:nvSpPr>
-          <p:cNvPr id="11" name="Text 9"/>
+          <p:cNvPr id="10" name="Text 8"/>
           <p:cNvSpPr txBox="1"/>
           <p:nvPr/>
         </p:nvSpPr>
@@ -2525,7 +2479,7 @@
       </p:sp>
       <p:sp>
         <p:nvSpPr>
-          <p:cNvPr id="12" name="Text 10"/>
+          <p:cNvPr id="11" name="Text 9"/>
           <p:cNvSpPr txBox="1"/>
           <p:nvPr/>
         </p:nvSpPr>
@@ -2564,7 +2518,7 @@
       </p:sp>
       <p:sp>
         <p:nvSpPr>
-          <p:cNvPr id="13" name="Text 11"/>
+          <p:cNvPr id="12" name="Text 10"/>
           <p:cNvSpPr txBox="1"/>
           <p:nvPr/>
         </p:nvSpPr>
@@ -2606,7 +2560,7 @@
       </p:sp>
       <p:sp>
         <p:nvSpPr>
-          <p:cNvPr id="14" name="Text 12"/>
+          <p:cNvPr id="13" name="Text 11"/>
           <p:cNvSpPr txBox="1"/>
           <p:nvPr/>
         </p:nvSpPr>
@@ -2645,7 +2599,7 @@
       </p:sp>
       <p:sp>
         <p:nvSpPr>
-          <p:cNvPr id="15" name="Text 13"/>
+          <p:cNvPr id="14" name="Text 12"/>
           <p:cNvSpPr txBox="1"/>
           <p:nvPr/>
         </p:nvSpPr>
@@ -2687,7 +2641,7 @@
       </p:sp>
       <p:sp>
         <p:nvSpPr>
-          <p:cNvPr id="16" name="Shape 14"/>
+          <p:cNvPr id="15" name="Shape 13"/>
           <p:cNvSpPr/>
           <p:nvPr/>
         </p:nvSpPr>
@@ -2707,7 +2661,7 @@
       </p:sp>
       <p:sp>
         <p:nvSpPr>
-          <p:cNvPr id="17" name="Text 15"/>
+          <p:cNvPr id="16" name="Text 14"/>
           <p:cNvSpPr txBox="1"/>
           <p:nvPr/>
         </p:nvSpPr>
@@ -2746,7 +2700,7 @@
       </p:sp>
       <p:sp>
         <p:nvSpPr>
-          <p:cNvPr id="18" name="Text 16"/>
+          <p:cNvPr id="17" name="Text 15"/>
           <p:cNvSpPr txBox="1"/>
           <p:nvPr/>
         </p:nvSpPr>
@@ -2785,7 +2739,7 @@
       </p:sp>
       <p:sp>
         <p:nvSpPr>
-          <p:cNvPr id="19" name="Text 17"/>
+          <p:cNvPr id="18" name="Text 16"/>
           <p:cNvSpPr txBox="1"/>
           <p:nvPr/>
         </p:nvSpPr>
@@ -2824,7 +2778,7 @@
       </p:sp>
       <p:sp>
         <p:nvSpPr>
-          <p:cNvPr id="20" name="Text 18"/>
+          <p:cNvPr id="19" name="Text 17"/>
           <p:cNvSpPr txBox="1"/>
           <p:nvPr/>
         </p:nvSpPr>
@@ -2866,7 +2820,7 @@
       </p:sp>
       <p:sp>
         <p:nvSpPr>
-          <p:cNvPr id="21" name="Text 19"/>
+          <p:cNvPr id="20" name="Text 18"/>
           <p:cNvSpPr txBox="1"/>
           <p:nvPr/>
         </p:nvSpPr>
@@ -2905,7 +2859,7 @@
       </p:sp>
       <p:sp>
         <p:nvSpPr>
-          <p:cNvPr id="22" name="Text 20"/>
+          <p:cNvPr id="21" name="Text 19"/>
           <p:cNvSpPr txBox="1"/>
           <p:nvPr/>
         </p:nvSpPr>
@@ -2947,7 +2901,7 @@
       </p:sp>
       <p:sp>
         <p:nvSpPr>
-          <p:cNvPr id="23" name="Text 21"/>
+          <p:cNvPr id="22" name="Text 20"/>
           <p:cNvSpPr txBox="1"/>
           <p:nvPr/>
         </p:nvSpPr>
@@ -2986,7 +2940,7 @@
       </p:sp>
       <p:sp>
         <p:nvSpPr>
-          <p:cNvPr id="24" name="Text 22"/>
+          <p:cNvPr id="23" name="Text 21"/>
           <p:cNvSpPr txBox="1"/>
           <p:nvPr/>
         </p:nvSpPr>
@@ -3028,7 +2982,7 @@
       </p:sp>
       <p:sp>
         <p:nvSpPr>
-          <p:cNvPr id="25" name="Shape 23"/>
+          <p:cNvPr id="24" name="Shape 22"/>
           <p:cNvSpPr/>
           <p:nvPr/>
         </p:nvSpPr>
@@ -3048,7 +3002,7 @@
       </p:sp>
       <p:sp>
         <p:nvSpPr>
-          <p:cNvPr id="26" name="Text 24"/>
+          <p:cNvPr id="25" name="Text 23"/>
           <p:cNvSpPr txBox="1"/>
           <p:nvPr/>
         </p:nvSpPr>
@@ -3087,7 +3041,7 @@
       </p:sp>
       <p:sp>
         <p:nvSpPr>
-          <p:cNvPr id="27" name="Text 25"/>
+          <p:cNvPr id="26" name="Text 24"/>
           <p:cNvSpPr txBox="1"/>
           <p:nvPr/>
         </p:nvSpPr>
@@ -3126,7 +3080,7 @@
       </p:sp>
       <p:sp>
         <p:nvSpPr>
-          <p:cNvPr id="28" name="Text 26"/>
+          <p:cNvPr id="27" name="Text 25"/>
           <p:cNvSpPr txBox="1"/>
           <p:nvPr/>
         </p:nvSpPr>
@@ -3165,7 +3119,7 @@
       </p:sp>
       <p:sp>
         <p:nvSpPr>
-          <p:cNvPr id="29" name="Text 27"/>
+          <p:cNvPr id="28" name="Text 26"/>
           <p:cNvSpPr txBox="1"/>
           <p:nvPr/>
         </p:nvSpPr>
@@ -3207,7 +3161,7 @@
       </p:sp>
       <p:sp>
         <p:nvSpPr>
-          <p:cNvPr id="30" name="Text 28"/>
+          <p:cNvPr id="29" name="Text 27"/>
           <p:cNvSpPr txBox="1"/>
           <p:nvPr/>
         </p:nvSpPr>
@@ -3246,7 +3200,7 @@
       </p:sp>
       <p:sp>
         <p:nvSpPr>
-          <p:cNvPr id="31" name="Text 29"/>
+          <p:cNvPr id="30" name="Text 28"/>
           <p:cNvSpPr txBox="1"/>
           <p:nvPr/>
         </p:nvSpPr>
@@ -3288,7 +3242,7 @@
       </p:sp>
       <p:sp>
         <p:nvSpPr>
-          <p:cNvPr id="32" name="Text 30"/>
+          <p:cNvPr id="31" name="Text 29"/>
           <p:cNvSpPr txBox="1"/>
           <p:nvPr/>
         </p:nvSpPr>
@@ -3327,7 +3281,7 @@
       </p:sp>
       <p:sp>
         <p:nvSpPr>
-          <p:cNvPr id="33" name="Text 31"/>
+          <p:cNvPr id="32" name="Text 30"/>
           <p:cNvSpPr txBox="1"/>
           <p:nvPr/>
         </p:nvSpPr>
@@ -3369,7 +3323,7 @@
       </p:sp>
       <p:sp>
         <p:nvSpPr>
-          <p:cNvPr id="34" name="Text 32"/>
+          <p:cNvPr id="33" name="Text 31"/>
           <p:cNvSpPr txBox="1"/>
           <p:nvPr/>
         </p:nvSpPr>
@@ -3411,7 +3365,7 @@
       </p:sp>
       <p:sp>
         <p:nvSpPr>
-          <p:cNvPr id="35" name="Text 33"/>
+          <p:cNvPr id="34" name="Text 32"/>
           <p:cNvSpPr txBox="1"/>
           <p:nvPr/>
         </p:nvSpPr>
@@ -3450,7 +3404,7 @@
       </p:sp>
       <p:sp>
         <p:nvSpPr>
-          <p:cNvPr id="36" name="Text 34"/>
+          <p:cNvPr id="35" name="Text 33"/>
           <p:cNvSpPr txBox="1"/>
           <p:nvPr/>
         </p:nvSpPr>
@@ -3521,36 +3475,13 @@
       </p:grpSpPr>
       <p:sp>
         <p:nvSpPr>
-          <p:cNvPr id="2" name="Shape 0"/>
-          <p:cNvSpPr/>
-          <p:nvPr/>
-        </p:nvSpPr>
-        <p:spPr>
-          <a:xfrm>
-            <a:off x="777240" y="580644"/>
-            <a:ext cx="237744" cy="0"/>
-          </a:xfrm>
-          <a:prstGeom prst="line">
-            <a:avLst/>
-          </a:prstGeom>
-          <a:noFill/>
-          <a:ln w="12700">
-            <a:solidFill>
-              <a:srgbClr val="11676A"/>
-            </a:solidFill>
-            <a:prstDash val="solid"/>
-          </a:ln>
-        </p:spPr>
-      </p:sp>
-      <p:sp>
-        <p:nvSpPr>
-          <p:cNvPr id="3" name="Text 1"/>
-          <p:cNvSpPr txBox="1"/>
-          <p:nvPr/>
-        </p:nvSpPr>
-        <p:spPr>
-          <a:xfrm>
-            <a:off x="1106424" y="461772"/>
+          <p:cNvPr id="2" name="Text 0"/>
+          <p:cNvSpPr txBox="1"/>
+          <p:nvPr/>
+        </p:nvSpPr>
+        <p:spPr>
+          <a:xfrm>
+            <a:off x="777240" y="461772"/>
             <a:ext cx="5486400" cy="237744"/>
           </a:xfrm>
           <a:prstGeom prst="rect">
@@ -3583,7 +3514,7 @@
       </p:sp>
       <p:sp>
         <p:nvSpPr>
-          <p:cNvPr id="4" name="Text 2"/>
+          <p:cNvPr id="3" name="Text 1"/>
           <p:cNvSpPr txBox="1"/>
           <p:nvPr/>
         </p:nvSpPr>
@@ -3625,7 +3556,7 @@
       </p:sp>
       <p:sp>
         <p:nvSpPr>
-          <p:cNvPr id="5" name="Text 3"/>
+          <p:cNvPr id="4" name="Text 2"/>
           <p:cNvSpPr txBox="1"/>
           <p:nvPr/>
         </p:nvSpPr>
@@ -3667,36 +3598,13 @@
       </p:sp>
       <p:sp>
         <p:nvSpPr>
-          <p:cNvPr id="6" name="Shape 4"/>
-          <p:cNvSpPr/>
-          <p:nvPr/>
-        </p:nvSpPr>
-        <p:spPr>
-          <a:xfrm>
-            <a:off x="777240" y="2234438"/>
-            <a:ext cx="10637215" cy="0"/>
-          </a:xfrm>
-          <a:prstGeom prst="line">
-            <a:avLst/>
-          </a:prstGeom>
-          <a:noFill/>
-          <a:ln w="12700">
-            <a:solidFill>
-              <a:srgbClr val="11676A"/>
-            </a:solidFill>
-            <a:prstDash val="solid"/>
-          </a:ln>
-        </p:spPr>
-      </p:sp>
-      <p:sp>
-        <p:nvSpPr>
-          <p:cNvPr id="7" name="Text 5"/>
-          <p:cNvSpPr txBox="1"/>
-          <p:nvPr/>
-        </p:nvSpPr>
-        <p:spPr>
-          <a:xfrm>
-            <a:off x="777240" y="2417318"/>
+          <p:cNvPr id="5" name="Text 3"/>
+          <p:cNvSpPr txBox="1"/>
+          <p:nvPr/>
+        </p:nvSpPr>
+        <p:spPr>
+          <a:xfrm>
+            <a:off x="777240" y="2362454"/>
             <a:ext cx="2487168" cy="182880"/>
           </a:xfrm>
           <a:prstGeom prst="rect">
@@ -3729,13 +3637,13 @@
       </p:sp>
       <p:sp>
         <p:nvSpPr>
-          <p:cNvPr id="8" name="Text 6"/>
-          <p:cNvSpPr txBox="1"/>
-          <p:nvPr/>
-        </p:nvSpPr>
-        <p:spPr>
-          <a:xfrm>
-            <a:off x="777240" y="2709926"/>
+          <p:cNvPr id="6" name="Text 4"/>
+          <p:cNvSpPr txBox="1"/>
+          <p:nvPr/>
+        </p:nvSpPr>
+        <p:spPr>
+          <a:xfrm>
+            <a:off x="777240" y="2655062"/>
             <a:ext cx="2395728" cy="566928"/>
           </a:xfrm>
           <a:prstGeom prst="rect">
@@ -3771,13 +3679,13 @@
       </p:sp>
       <p:sp>
         <p:nvSpPr>
-          <p:cNvPr id="9" name="Text 7"/>
-          <p:cNvSpPr txBox="1"/>
-          <p:nvPr/>
-        </p:nvSpPr>
-        <p:spPr>
-          <a:xfrm>
-            <a:off x="777240" y="3331718"/>
+          <p:cNvPr id="7" name="Text 5"/>
+          <p:cNvSpPr txBox="1"/>
+          <p:nvPr/>
+        </p:nvSpPr>
+        <p:spPr>
+          <a:xfrm>
+            <a:off x="777240" y="3276854"/>
             <a:ext cx="2395728" cy="1463040"/>
           </a:xfrm>
           <a:prstGeom prst="rect">
@@ -3813,13 +3721,13 @@
       </p:sp>
       <p:sp>
         <p:nvSpPr>
-          <p:cNvPr id="10" name="Text 8"/>
-          <p:cNvSpPr txBox="1"/>
-          <p:nvPr/>
-        </p:nvSpPr>
-        <p:spPr>
-          <a:xfrm>
-            <a:off x="3483864" y="2417318"/>
+          <p:cNvPr id="8" name="Text 6"/>
+          <p:cNvSpPr txBox="1"/>
+          <p:nvPr/>
+        </p:nvSpPr>
+        <p:spPr>
+          <a:xfrm>
+            <a:off x="3483864" y="2362454"/>
             <a:ext cx="2487168" cy="182880"/>
           </a:xfrm>
           <a:prstGeom prst="rect">
@@ -3852,13 +3760,13 @@
       </p:sp>
       <p:sp>
         <p:nvSpPr>
-          <p:cNvPr id="11" name="Text 9"/>
-          <p:cNvSpPr txBox="1"/>
-          <p:nvPr/>
-        </p:nvSpPr>
-        <p:spPr>
-          <a:xfrm>
-            <a:off x="3483864" y="2709926"/>
+          <p:cNvPr id="9" name="Text 7"/>
+          <p:cNvSpPr txBox="1"/>
+          <p:nvPr/>
+        </p:nvSpPr>
+        <p:spPr>
+          <a:xfrm>
+            <a:off x="3483864" y="2655062"/>
             <a:ext cx="2395728" cy="566928"/>
           </a:xfrm>
           <a:prstGeom prst="rect">
@@ -3894,13 +3802,13 @@
       </p:sp>
       <p:sp>
         <p:nvSpPr>
-          <p:cNvPr id="12" name="Text 10"/>
-          <p:cNvSpPr txBox="1"/>
-          <p:nvPr/>
-        </p:nvSpPr>
-        <p:spPr>
-          <a:xfrm>
-            <a:off x="3483864" y="3331718"/>
+          <p:cNvPr id="10" name="Text 8"/>
+          <p:cNvSpPr txBox="1"/>
+          <p:nvPr/>
+        </p:nvSpPr>
+        <p:spPr>
+          <a:xfrm>
+            <a:off x="3483864" y="3276854"/>
             <a:ext cx="2395728" cy="1463040"/>
           </a:xfrm>
           <a:prstGeom prst="rect">
@@ -3936,13 +3844,13 @@
       </p:sp>
       <p:sp>
         <p:nvSpPr>
-          <p:cNvPr id="13" name="Text 11"/>
-          <p:cNvSpPr txBox="1"/>
-          <p:nvPr/>
-        </p:nvSpPr>
-        <p:spPr>
-          <a:xfrm>
-            <a:off x="6190488" y="2417318"/>
+          <p:cNvPr id="11" name="Text 9"/>
+          <p:cNvSpPr txBox="1"/>
+          <p:nvPr/>
+        </p:nvSpPr>
+        <p:spPr>
+          <a:xfrm>
+            <a:off x="6190488" y="2362454"/>
             <a:ext cx="2487168" cy="182880"/>
           </a:xfrm>
           <a:prstGeom prst="rect">
@@ -3975,13 +3883,13 @@
       </p:sp>
       <p:sp>
         <p:nvSpPr>
-          <p:cNvPr id="14" name="Text 12"/>
-          <p:cNvSpPr txBox="1"/>
-          <p:nvPr/>
-        </p:nvSpPr>
-        <p:spPr>
-          <a:xfrm>
-            <a:off x="6190488" y="2709926"/>
+          <p:cNvPr id="12" name="Text 10"/>
+          <p:cNvSpPr txBox="1"/>
+          <p:nvPr/>
+        </p:nvSpPr>
+        <p:spPr>
+          <a:xfrm>
+            <a:off x="6190488" y="2655062"/>
             <a:ext cx="2395728" cy="566928"/>
           </a:xfrm>
           <a:prstGeom prst="rect">
@@ -4017,13 +3925,13 @@
       </p:sp>
       <p:sp>
         <p:nvSpPr>
-          <p:cNvPr id="15" name="Text 13"/>
-          <p:cNvSpPr txBox="1"/>
-          <p:nvPr/>
-        </p:nvSpPr>
-        <p:spPr>
-          <a:xfrm>
-            <a:off x="6190488" y="3331718"/>
+          <p:cNvPr id="13" name="Text 11"/>
+          <p:cNvSpPr txBox="1"/>
+          <p:nvPr/>
+        </p:nvSpPr>
+        <p:spPr>
+          <a:xfrm>
+            <a:off x="6190488" y="3276854"/>
             <a:ext cx="2395728" cy="1463040"/>
           </a:xfrm>
           <a:prstGeom prst="rect">
@@ -4059,13 +3967,13 @@
       </p:sp>
       <p:sp>
         <p:nvSpPr>
-          <p:cNvPr id="16" name="Text 14"/>
-          <p:cNvSpPr txBox="1"/>
-          <p:nvPr/>
-        </p:nvSpPr>
-        <p:spPr>
-          <a:xfrm>
-            <a:off x="8897112" y="2417318"/>
+          <p:cNvPr id="14" name="Text 12"/>
+          <p:cNvSpPr txBox="1"/>
+          <p:nvPr/>
+        </p:nvSpPr>
+        <p:spPr>
+          <a:xfrm>
+            <a:off x="8897112" y="2362454"/>
             <a:ext cx="2487168" cy="182880"/>
           </a:xfrm>
           <a:prstGeom prst="rect">
@@ -4098,13 +4006,13 @@
       </p:sp>
       <p:sp>
         <p:nvSpPr>
-          <p:cNvPr id="17" name="Text 15"/>
-          <p:cNvSpPr txBox="1"/>
-          <p:nvPr/>
-        </p:nvSpPr>
-        <p:spPr>
-          <a:xfrm>
-            <a:off x="8897112" y="2709926"/>
+          <p:cNvPr id="15" name="Text 13"/>
+          <p:cNvSpPr txBox="1"/>
+          <p:nvPr/>
+        </p:nvSpPr>
+        <p:spPr>
+          <a:xfrm>
+            <a:off x="8897112" y="2655062"/>
             <a:ext cx="2395728" cy="566928"/>
           </a:xfrm>
           <a:prstGeom prst="rect">
@@ -4140,13 +4048,13 @@
       </p:sp>
       <p:sp>
         <p:nvSpPr>
-          <p:cNvPr id="18" name="Text 16"/>
-          <p:cNvSpPr txBox="1"/>
-          <p:nvPr/>
-        </p:nvSpPr>
-        <p:spPr>
-          <a:xfrm>
-            <a:off x="8897112" y="3331718"/>
+          <p:cNvPr id="16" name="Text 14"/>
+          <p:cNvSpPr txBox="1"/>
+          <p:nvPr/>
+        </p:nvSpPr>
+        <p:spPr>
+          <a:xfrm>
+            <a:off x="8897112" y="3276854"/>
             <a:ext cx="2395728" cy="1463040"/>
           </a:xfrm>
           <a:prstGeom prst="rect">
@@ -4182,7 +4090,7 @@
       </p:sp>
       <p:sp>
         <p:nvSpPr>
-          <p:cNvPr id="19" name="Shape 17"/>
+          <p:cNvPr id="17" name="Shape 15"/>
           <p:cNvSpPr/>
           <p:nvPr/>
         </p:nvSpPr>
@@ -4202,7 +4110,7 @@
       </p:sp>
       <p:sp>
         <p:nvSpPr>
-          <p:cNvPr id="20" name="Text 18"/>
+          <p:cNvPr id="18" name="Text 16"/>
           <p:cNvSpPr txBox="1"/>
           <p:nvPr/>
         </p:nvSpPr>
@@ -4241,7 +4149,7 @@
       </p:sp>
       <p:pic>
         <p:nvPicPr>
-          <p:cNvPr id="21" name="Image 0" descr="./assets/ref-mercedes-benz.png">    </p:cNvPr>
+          <p:cNvPr id="19" name="Image 0" descr="./assets/ref-mercedes-benz.png">    </p:cNvPr>
           <p:cNvPicPr>
             <a:picLocks noChangeAspect="1"/>
           </p:cNvPicPr>
@@ -4265,7 +4173,7 @@
       </p:pic>
       <p:pic>
         <p:nvPicPr>
-          <p:cNvPr id="22" name="Image 1" descr="./assets/ref-pwc.png">    </p:cNvPr>
+          <p:cNvPr id="20" name="Image 1" descr="./assets/ref-pwc.png">    </p:cNvPr>
           <p:cNvPicPr>
             <a:picLocks noChangeAspect="1"/>
           </p:cNvPicPr>
@@ -4289,7 +4197,7 @@
       </p:pic>
       <p:pic>
         <p:nvPicPr>
-          <p:cNvPr id="23" name="Image 2" descr="./assets/ref-fusion-consulting.png">    </p:cNvPr>
+          <p:cNvPr id="21" name="Image 2" descr="./assets/ref-fusion-consulting.png">    </p:cNvPr>
           <p:cNvPicPr>
             <a:picLocks noChangeAspect="1"/>
           </p:cNvPicPr>
@@ -4313,7 +4221,7 @@
       </p:pic>
       <p:pic>
         <p:nvPicPr>
-          <p:cNvPr id="24" name="Image 3" descr="./assets/ref-boehringer-ingelheim.png">    </p:cNvPr>
+          <p:cNvPr id="22" name="Image 3" descr="./assets/ref-boehringer-ingelheim.png">    </p:cNvPr>
           <p:cNvPicPr>
             <a:picLocks noChangeAspect="1"/>
           </p:cNvPicPr>
@@ -4337,7 +4245,7 @@
       </p:pic>
       <p:pic>
         <p:nvPicPr>
-          <p:cNvPr id="25" name="Image 4" descr="./assets/ref-wavin.png">    </p:cNvPr>
+          <p:cNvPr id="23" name="Image 4" descr="./assets/ref-wavin.png">    </p:cNvPr>
           <p:cNvPicPr>
             <a:picLocks noChangeAspect="1"/>
           </p:cNvPicPr>
@@ -4361,7 +4269,7 @@
       </p:pic>
       <p:pic>
         <p:nvPicPr>
-          <p:cNvPr id="26" name="Image 5" descr="./assets/ref-imerys.png">    </p:cNvPr>
+          <p:cNvPr id="24" name="Image 5" descr="./assets/ref-imerys.png">    </p:cNvPr>
           <p:cNvPicPr>
             <a:picLocks noChangeAspect="1"/>
           </p:cNvPicPr>
@@ -4385,7 +4293,7 @@
       </p:pic>
       <p:pic>
         <p:nvPicPr>
-          <p:cNvPr id="27" name="Image 6" descr="./assets/ref-gsk.png">    </p:cNvPr>
+          <p:cNvPr id="25" name="Image 6" descr="./assets/ref-gsk.png">    </p:cNvPr>
           <p:cNvPicPr>
             <a:picLocks noChangeAspect="1"/>
           </p:cNvPicPr>
@@ -4409,7 +4317,7 @@
       </p:pic>
       <p:pic>
         <p:nvPicPr>
-          <p:cNvPr id="28" name="Image 7" descr="./assets/ref-beko.png">    </p:cNvPr>
+          <p:cNvPr id="26" name="Image 7" descr="./assets/ref-beko.png">    </p:cNvPr>
           <p:cNvPicPr>
             <a:picLocks noChangeAspect="1"/>
           </p:cNvPicPr>
@@ -4433,7 +4341,7 @@
       </p:pic>
       <p:pic>
         <p:nvPicPr>
-          <p:cNvPr id="29" name="Image 8" descr="./assets/ref-peri.png">    </p:cNvPr>
+          <p:cNvPr id="27" name="Image 8" descr="./assets/ref-peri.png">    </p:cNvPr>
           <p:cNvPicPr>
             <a:picLocks noChangeAspect="1"/>
           </p:cNvPicPr>
@@ -4457,7 +4365,7 @@
       </p:pic>
       <p:sp>
         <p:nvSpPr>
-          <p:cNvPr id="30" name="Text 19"/>
+          <p:cNvPr id="28" name="Text 17"/>
           <p:cNvSpPr txBox="1"/>
           <p:nvPr/>
         </p:nvSpPr>
@@ -4496,7 +4404,7 @@
       </p:sp>
       <p:sp>
         <p:nvSpPr>
-          <p:cNvPr id="31" name="Text 20"/>
+          <p:cNvPr id="29" name="Text 18"/>
           <p:cNvSpPr txBox="1"/>
           <p:nvPr/>
         </p:nvSpPr>
@@ -4615,36 +4523,13 @@
       </p:pic>
       <p:sp>
         <p:nvSpPr>
-          <p:cNvPr id="4" name="Shape 0"/>
-          <p:cNvSpPr/>
-          <p:nvPr/>
-        </p:nvSpPr>
-        <p:spPr>
-          <a:xfrm>
-            <a:off x="777240" y="2208276"/>
-            <a:ext cx="237744" cy="0"/>
-          </a:xfrm>
-          <a:prstGeom prst="line">
-            <a:avLst/>
-          </a:prstGeom>
-          <a:noFill/>
-          <a:ln w="12700">
-            <a:solidFill>
-              <a:srgbClr val="F5DCA4"/>
-            </a:solidFill>
-            <a:prstDash val="solid"/>
-          </a:ln>
-        </p:spPr>
-      </p:sp>
-      <p:sp>
-        <p:nvSpPr>
-          <p:cNvPr id="5" name="Text 1"/>
-          <p:cNvSpPr txBox="1"/>
-          <p:nvPr/>
-        </p:nvSpPr>
-        <p:spPr>
-          <a:xfrm>
-            <a:off x="1106424" y="2089404"/>
+          <p:cNvPr id="4" name="Text 0"/>
+          <p:cNvSpPr txBox="1"/>
+          <p:nvPr/>
+        </p:nvSpPr>
+        <p:spPr>
+          <a:xfrm>
+            <a:off x="777240" y="2089404"/>
             <a:ext cx="5486400" cy="237744"/>
           </a:xfrm>
           <a:prstGeom prst="rect">
@@ -4677,7 +4562,7 @@
       </p:sp>
       <p:sp>
         <p:nvSpPr>
-          <p:cNvPr id="6" name="Text 2"/>
+          <p:cNvPr id="5" name="Text 1"/>
           <p:cNvSpPr txBox="1"/>
           <p:nvPr/>
         </p:nvSpPr>
@@ -4759,7 +4644,7 @@
       </p:sp>
       <p:sp>
         <p:nvSpPr>
-          <p:cNvPr id="7" name="Text 3"/>
+          <p:cNvPr id="6" name="Text 2"/>
           <p:cNvSpPr txBox="1"/>
           <p:nvPr/>
         </p:nvSpPr>
@@ -4801,7 +4686,7 @@
       </p:sp>
       <p:sp>
         <p:nvSpPr>
-          <p:cNvPr id="8" name="Text 4"/>
+          <p:cNvPr id="7" name="Text 3"/>
           <p:cNvSpPr txBox="1"/>
           <p:nvPr/>
         </p:nvSpPr>
@@ -4840,7 +4725,7 @@
       </p:sp>
       <p:sp>
         <p:nvSpPr>
-          <p:cNvPr id="9" name="Text 5"/>
+          <p:cNvPr id="8" name="Text 4"/>
           <p:cNvSpPr txBox="1"/>
           <p:nvPr/>
         </p:nvSpPr>
@@ -4882,7 +4767,7 @@
       </p:sp>
       <p:sp>
         <p:nvSpPr>
-          <p:cNvPr id="10" name="Text 6"/>
+          <p:cNvPr id="9" name="Text 5"/>
           <p:cNvSpPr txBox="1"/>
           <p:nvPr/>
         </p:nvSpPr>
@@ -4921,7 +4806,7 @@
       </p:sp>
       <p:sp>
         <p:nvSpPr>
-          <p:cNvPr id="11" name="Text 7"/>
+          <p:cNvPr id="10" name="Text 6"/>
           <p:cNvSpPr txBox="1"/>
           <p:nvPr/>
         </p:nvSpPr>
@@ -4963,7 +4848,7 @@
       </p:sp>
       <p:sp>
         <p:nvSpPr>
-          <p:cNvPr id="12" name="Text 8"/>
+          <p:cNvPr id="11" name="Text 7"/>
           <p:cNvSpPr txBox="1"/>
           <p:nvPr/>
         </p:nvSpPr>
@@ -5002,7 +4887,7 @@
       </p:sp>
       <p:sp>
         <p:nvSpPr>
-          <p:cNvPr id="13" name="Text 9"/>
+          <p:cNvPr id="12" name="Text 8"/>
           <p:cNvSpPr txBox="1"/>
           <p:nvPr/>
         </p:nvSpPr>
@@ -5044,7 +4929,7 @@
       </p:sp>
       <p:sp>
         <p:nvSpPr>
-          <p:cNvPr id="14" name="Text 10"/>
+          <p:cNvPr id="13" name="Text 9"/>
           <p:cNvSpPr txBox="1"/>
           <p:nvPr/>
         </p:nvSpPr>
@@ -5083,7 +4968,7 @@
       </p:sp>
       <p:sp>
         <p:nvSpPr>
-          <p:cNvPr id="15" name="Text 11"/>
+          <p:cNvPr id="14" name="Text 10"/>
           <p:cNvSpPr txBox="1"/>
           <p:nvPr/>
         </p:nvSpPr>
@@ -5145,7 +5030,7 @@
       </p:sp>
       <p:sp>
         <p:nvSpPr>
-          <p:cNvPr id="16" name="Text 12"/>
+          <p:cNvPr id="15" name="Text 11"/>
           <p:cNvSpPr txBox="1"/>
           <p:nvPr/>
         </p:nvSpPr>
@@ -5184,7 +5069,7 @@
       </p:sp>
       <p:sp>
         <p:nvSpPr>
-          <p:cNvPr id="17" name="Text 13"/>
+          <p:cNvPr id="16" name="Text 12"/>
           <p:cNvSpPr txBox="1"/>
           <p:nvPr/>
         </p:nvSpPr>
@@ -5226,7 +5111,7 @@
       </p:sp>
       <p:sp>
         <p:nvSpPr>
-          <p:cNvPr id="18" name="Text 14"/>
+          <p:cNvPr id="17" name="Text 13"/>
           <p:cNvSpPr txBox="1"/>
           <p:nvPr/>
         </p:nvSpPr>
@@ -5265,7 +5150,7 @@
       </p:sp>
       <p:sp>
         <p:nvSpPr>
-          <p:cNvPr id="19" name="Text 15"/>
+          <p:cNvPr id="18" name="Text 14"/>
           <p:cNvSpPr txBox="1"/>
           <p:nvPr/>
         </p:nvSpPr>
@@ -5307,7 +5192,7 @@
       </p:sp>
       <p:sp>
         <p:nvSpPr>
-          <p:cNvPr id="20" name="Text 16"/>
+          <p:cNvPr id="19" name="Text 15"/>
           <p:cNvSpPr txBox="1"/>
           <p:nvPr/>
         </p:nvSpPr>
@@ -5378,36 +5263,13 @@
       </p:grpSpPr>
       <p:sp>
         <p:nvSpPr>
-          <p:cNvPr id="2" name="Shape 0"/>
-          <p:cNvSpPr/>
-          <p:nvPr/>
-        </p:nvSpPr>
-        <p:spPr>
-          <a:xfrm>
-            <a:off x="777240" y="580644"/>
-            <a:ext cx="237744" cy="0"/>
-          </a:xfrm>
-          <a:prstGeom prst="line">
-            <a:avLst/>
-          </a:prstGeom>
-          <a:noFill/>
-          <a:ln w="12700">
-            <a:solidFill>
-              <a:srgbClr val="11676A"/>
-            </a:solidFill>
-            <a:prstDash val="solid"/>
-          </a:ln>
-        </p:spPr>
-      </p:sp>
-      <p:sp>
-        <p:nvSpPr>
-          <p:cNvPr id="3" name="Text 1"/>
-          <p:cNvSpPr txBox="1"/>
-          <p:nvPr/>
-        </p:nvSpPr>
-        <p:spPr>
-          <a:xfrm>
-            <a:off x="1106424" y="461772"/>
+          <p:cNvPr id="2" name="Text 0"/>
+          <p:cNvSpPr txBox="1"/>
+          <p:nvPr/>
+        </p:nvSpPr>
+        <p:spPr>
+          <a:xfrm>
+            <a:off x="777240" y="461772"/>
             <a:ext cx="5486400" cy="237744"/>
           </a:xfrm>
           <a:prstGeom prst="rect">
@@ -5440,7 +5302,7 @@
       </p:sp>
       <p:sp>
         <p:nvSpPr>
-          <p:cNvPr id="4" name="Text 2"/>
+          <p:cNvPr id="3" name="Text 1"/>
           <p:cNvSpPr txBox="1"/>
           <p:nvPr/>
         </p:nvSpPr>
@@ -5482,7 +5344,7 @@
       </p:sp>
       <p:sp>
         <p:nvSpPr>
-          <p:cNvPr id="5" name="Text 3"/>
+          <p:cNvPr id="4" name="Text 2"/>
           <p:cNvSpPr txBox="1"/>
           <p:nvPr/>
         </p:nvSpPr>
@@ -5524,7 +5386,7 @@
       </p:sp>
       <p:sp>
         <p:nvSpPr>
-          <p:cNvPr id="6" name="Text 4"/>
+          <p:cNvPr id="5" name="Text 3"/>
           <p:cNvSpPr txBox="1"/>
           <p:nvPr/>
         </p:nvSpPr>
@@ -5566,7 +5428,7 @@
       </p:sp>
       <p:sp>
         <p:nvSpPr>
-          <p:cNvPr id="7" name="Text 5"/>
+          <p:cNvPr id="6" name="Text 4"/>
           <p:cNvSpPr txBox="1"/>
           <p:nvPr/>
         </p:nvSpPr>
@@ -5608,7 +5470,7 @@
       </p:sp>
       <p:sp>
         <p:nvSpPr>
-          <p:cNvPr id="8" name="Text 6"/>
+          <p:cNvPr id="7" name="Text 5"/>
           <p:cNvSpPr txBox="1"/>
           <p:nvPr/>
         </p:nvSpPr>
@@ -5647,7 +5509,7 @@
       </p:sp>
       <p:sp>
         <p:nvSpPr>
-          <p:cNvPr id="9" name="Text 7"/>
+          <p:cNvPr id="8" name="Text 6"/>
           <p:cNvSpPr txBox="1"/>
           <p:nvPr/>
         </p:nvSpPr>
@@ -5686,7 +5548,7 @@
       </p:sp>
       <p:sp>
         <p:nvSpPr>
-          <p:cNvPr id="10" name="Text 8"/>
+          <p:cNvPr id="9" name="Text 7"/>
           <p:cNvSpPr txBox="1"/>
           <p:nvPr/>
         </p:nvSpPr>
@@ -5725,7 +5587,7 @@
       </p:sp>
       <p:sp>
         <p:nvSpPr>
-          <p:cNvPr id="11" name="Text 9"/>
+          <p:cNvPr id="10" name="Text 8"/>
           <p:cNvSpPr txBox="1"/>
           <p:nvPr/>
         </p:nvSpPr>
@@ -5764,7 +5626,7 @@
       </p:sp>
       <p:sp>
         <p:nvSpPr>
-          <p:cNvPr id="12" name="Text 10"/>
+          <p:cNvPr id="11" name="Text 9"/>
           <p:cNvSpPr txBox="1"/>
           <p:nvPr/>
         </p:nvSpPr>
@@ -5803,7 +5665,7 @@
       </p:sp>
       <p:sp>
         <p:nvSpPr>
-          <p:cNvPr id="13" name="Text 11"/>
+          <p:cNvPr id="12" name="Text 10"/>
           <p:cNvSpPr txBox="1"/>
           <p:nvPr/>
         </p:nvSpPr>
@@ -5842,7 +5704,7 @@
       </p:sp>
       <p:sp>
         <p:nvSpPr>
-          <p:cNvPr id="14" name="Text 12"/>
+          <p:cNvPr id="13" name="Text 11"/>
           <p:cNvSpPr txBox="1"/>
           <p:nvPr/>
         </p:nvSpPr>
@@ -5884,7 +5746,7 @@
       </p:sp>
       <p:sp>
         <p:nvSpPr>
-          <p:cNvPr id="15" name="Shape 13"/>
+          <p:cNvPr id="14" name="Shape 12"/>
           <p:cNvSpPr/>
           <p:nvPr/>
         </p:nvSpPr>
@@ -5904,7 +5766,7 @@
       </p:sp>
       <p:sp>
         <p:nvSpPr>
-          <p:cNvPr id="16" name="Text 14"/>
+          <p:cNvPr id="15" name="Text 13"/>
           <p:cNvSpPr txBox="1"/>
           <p:nvPr/>
         </p:nvSpPr>
@@ -5943,7 +5805,7 @@
       </p:sp>
       <p:sp>
         <p:nvSpPr>
-          <p:cNvPr id="17" name="Text 15"/>
+          <p:cNvPr id="16" name="Text 14"/>
           <p:cNvSpPr txBox="1"/>
           <p:nvPr/>
         </p:nvSpPr>
@@ -5996,7 +5858,7 @@
       </p:sp>
       <p:sp>
         <p:nvSpPr>
-          <p:cNvPr id="18" name="Text 16"/>
+          <p:cNvPr id="17" name="Text 15"/>
           <p:cNvSpPr txBox="1"/>
           <p:nvPr/>
         </p:nvSpPr>
@@ -6035,7 +5897,7 @@
       </p:sp>
       <p:sp>
         <p:nvSpPr>
-          <p:cNvPr id="19" name="Text 17"/>
+          <p:cNvPr id="18" name="Text 16"/>
           <p:cNvSpPr txBox="1"/>
           <p:nvPr/>
         </p:nvSpPr>
@@ -6077,7 +5939,7 @@
       </p:sp>
       <p:sp>
         <p:nvSpPr>
-          <p:cNvPr id="20" name="Text 18"/>
+          <p:cNvPr id="19" name="Text 17"/>
           <p:cNvSpPr txBox="1"/>
           <p:nvPr/>
         </p:nvSpPr>
@@ -6116,7 +5978,7 @@
       </p:sp>
       <p:sp>
         <p:nvSpPr>
-          <p:cNvPr id="21" name="Text 19"/>
+          <p:cNvPr id="20" name="Text 18"/>
           <p:cNvSpPr txBox="1"/>
           <p:nvPr/>
         </p:nvSpPr>
@@ -6158,7 +6020,7 @@
       </p:sp>
       <p:sp>
         <p:nvSpPr>
-          <p:cNvPr id="22" name="Text 20"/>
+          <p:cNvPr id="21" name="Text 19"/>
           <p:cNvSpPr txBox="1"/>
           <p:nvPr/>
         </p:nvSpPr>
@@ -6197,7 +6059,7 @@
       </p:sp>
       <p:sp>
         <p:nvSpPr>
-          <p:cNvPr id="23" name="Text 21"/>
+          <p:cNvPr id="22" name="Text 20"/>
           <p:cNvSpPr txBox="1"/>
           <p:nvPr/>
         </p:nvSpPr>
@@ -6239,7 +6101,7 @@
       </p:sp>
       <p:sp>
         <p:nvSpPr>
-          <p:cNvPr id="24" name="Text 22"/>
+          <p:cNvPr id="23" name="Text 21"/>
           <p:cNvSpPr txBox="1"/>
           <p:nvPr/>
         </p:nvSpPr>
@@ -6310,36 +6172,13 @@
       </p:grpSpPr>
       <p:sp>
         <p:nvSpPr>
-          <p:cNvPr id="2" name="Shape 0"/>
-          <p:cNvSpPr/>
-          <p:nvPr/>
-        </p:nvSpPr>
-        <p:spPr>
-          <a:xfrm>
-            <a:off x="777240" y="580644"/>
-            <a:ext cx="237744" cy="0"/>
-          </a:xfrm>
-          <a:prstGeom prst="line">
-            <a:avLst/>
-          </a:prstGeom>
-          <a:noFill/>
-          <a:ln w="12700">
-            <a:solidFill>
-              <a:srgbClr val="11676A"/>
-            </a:solidFill>
-            <a:prstDash val="solid"/>
-          </a:ln>
-        </p:spPr>
-      </p:sp>
-      <p:sp>
-        <p:nvSpPr>
-          <p:cNvPr id="3" name="Text 1"/>
-          <p:cNvSpPr txBox="1"/>
-          <p:nvPr/>
-        </p:nvSpPr>
-        <p:spPr>
-          <a:xfrm>
-            <a:off x="1106424" y="461772"/>
+          <p:cNvPr id="2" name="Text 0"/>
+          <p:cNvSpPr txBox="1"/>
+          <p:nvPr/>
+        </p:nvSpPr>
+        <p:spPr>
+          <a:xfrm>
+            <a:off x="777240" y="461772"/>
             <a:ext cx="5486400" cy="237744"/>
           </a:xfrm>
           <a:prstGeom prst="rect">
@@ -6372,7 +6211,7 @@
       </p:sp>
       <p:sp>
         <p:nvSpPr>
-          <p:cNvPr id="4" name="Text 2"/>
+          <p:cNvPr id="3" name="Text 1"/>
           <p:cNvSpPr txBox="1"/>
           <p:nvPr/>
         </p:nvSpPr>
@@ -6414,7 +6253,7 @@
       </p:sp>
       <p:pic>
         <p:nvPicPr>
-          <p:cNvPr id="5" name="Image 0" descr="./assets/fig-finance.jpg">    </p:cNvPr>
+          <p:cNvPr id="4" name="Image 0" descr="./assets/fig-finance.jpg">    </p:cNvPr>
           <p:cNvPicPr>
             <a:picLocks noChangeAspect="1"/>
           </p:cNvPicPr>
@@ -6438,7 +6277,7 @@
       </p:pic>
       <p:sp>
         <p:nvSpPr>
-          <p:cNvPr id="6" name="Text 3"/>
+          <p:cNvPr id="5" name="Text 2"/>
           <p:cNvSpPr txBox="1"/>
           <p:nvPr/>
         </p:nvSpPr>
@@ -6477,7 +6316,7 @@
       </p:sp>
       <p:sp>
         <p:nvSpPr>
-          <p:cNvPr id="7" name="Text 4"/>
+          <p:cNvPr id="6" name="Text 3"/>
           <p:cNvSpPr txBox="1"/>
           <p:nvPr/>
         </p:nvSpPr>
@@ -6516,7 +6355,7 @@
       </p:sp>
       <p:sp>
         <p:nvSpPr>
-          <p:cNvPr id="8" name="Text 5"/>
+          <p:cNvPr id="7" name="Text 4"/>
           <p:cNvSpPr txBox="1"/>
           <p:nvPr/>
         </p:nvSpPr>
@@ -6558,7 +6397,7 @@
       </p:sp>
       <p:sp>
         <p:nvSpPr>
-          <p:cNvPr id="9" name="Text 6"/>
+          <p:cNvPr id="8" name="Text 5"/>
           <p:cNvSpPr txBox="1"/>
           <p:nvPr/>
         </p:nvSpPr>
@@ -6597,7 +6436,7 @@
       </p:sp>
       <p:sp>
         <p:nvSpPr>
-          <p:cNvPr id="10" name="Text 7"/>
+          <p:cNvPr id="9" name="Text 6"/>
           <p:cNvSpPr txBox="1"/>
           <p:nvPr/>
         </p:nvSpPr>
@@ -6636,7 +6475,7 @@
       </p:sp>
       <p:sp>
         <p:nvSpPr>
-          <p:cNvPr id="11" name="Text 8"/>
+          <p:cNvPr id="10" name="Text 7"/>
           <p:cNvSpPr txBox="1"/>
           <p:nvPr/>
         </p:nvSpPr>
@@ -6678,7 +6517,7 @@
       </p:sp>
       <p:sp>
         <p:nvSpPr>
-          <p:cNvPr id="12" name="Text 9"/>
+          <p:cNvPr id="11" name="Text 8"/>
           <p:cNvSpPr txBox="1"/>
           <p:nvPr/>
         </p:nvSpPr>
@@ -6717,7 +6556,7 @@
       </p:sp>
       <p:sp>
         <p:nvSpPr>
-          <p:cNvPr id="13" name="Text 10"/>
+          <p:cNvPr id="12" name="Text 9"/>
           <p:cNvSpPr txBox="1"/>
           <p:nvPr/>
         </p:nvSpPr>
@@ -6756,7 +6595,7 @@
       </p:sp>
       <p:sp>
         <p:nvSpPr>
-          <p:cNvPr id="14" name="Text 11"/>
+          <p:cNvPr id="13" name="Text 10"/>
           <p:cNvSpPr txBox="1"/>
           <p:nvPr/>
         </p:nvSpPr>
@@ -6798,7 +6637,7 @@
       </p:sp>
       <p:sp>
         <p:nvSpPr>
-          <p:cNvPr id="15" name="Text 12"/>
+          <p:cNvPr id="14" name="Text 11"/>
           <p:cNvSpPr txBox="1"/>
           <p:nvPr/>
         </p:nvSpPr>
@@ -6837,7 +6676,7 @@
       </p:sp>
       <p:sp>
         <p:nvSpPr>
-          <p:cNvPr id="16" name="Text 13"/>
+          <p:cNvPr id="15" name="Text 12"/>
           <p:cNvSpPr txBox="1"/>
           <p:nvPr/>
         </p:nvSpPr>
@@ -6888,7 +6727,7 @@
     <p:bg>
       <p:bgPr>
         <a:solidFill>
-          <a:srgbClr val="F7F8F7"/>
+          <a:srgbClr val="FFFFFF"/>
         </a:solidFill>
       </p:bgPr>
     </p:bg>
@@ -6908,36 +6747,13 @@
       </p:grpSpPr>
       <p:sp>
         <p:nvSpPr>
-          <p:cNvPr id="2" name="Shape 0"/>
-          <p:cNvSpPr/>
-          <p:nvPr/>
-        </p:nvSpPr>
-        <p:spPr>
-          <a:xfrm>
-            <a:off x="777240" y="580644"/>
-            <a:ext cx="237744" cy="0"/>
-          </a:xfrm>
-          <a:prstGeom prst="line">
-            <a:avLst/>
-          </a:prstGeom>
-          <a:noFill/>
-          <a:ln w="12700">
-            <a:solidFill>
-              <a:srgbClr val="11676A"/>
-            </a:solidFill>
-            <a:prstDash val="solid"/>
-          </a:ln>
-        </p:spPr>
-      </p:sp>
-      <p:sp>
-        <p:nvSpPr>
-          <p:cNvPr id="3" name="Text 1"/>
-          <p:cNvSpPr txBox="1"/>
-          <p:nvPr/>
-        </p:nvSpPr>
-        <p:spPr>
-          <a:xfrm>
-            <a:off x="1106424" y="461772"/>
+          <p:cNvPr id="2" name="Text 0"/>
+          <p:cNvSpPr txBox="1"/>
+          <p:nvPr/>
+        </p:nvSpPr>
+        <p:spPr>
+          <a:xfrm>
+            <a:off x="777240" y="461772"/>
             <a:ext cx="5486400" cy="237744"/>
           </a:xfrm>
           <a:prstGeom prst="rect">
@@ -6970,7 +6786,7 @@
       </p:sp>
       <p:sp>
         <p:nvSpPr>
-          <p:cNvPr id="4" name="Text 2"/>
+          <p:cNvPr id="3" name="Text 1"/>
           <p:cNvSpPr txBox="1"/>
           <p:nvPr/>
         </p:nvSpPr>
@@ -7012,7 +6828,7 @@
       </p:sp>
       <p:sp>
         <p:nvSpPr>
-          <p:cNvPr id="5" name="Text 3"/>
+          <p:cNvPr id="4" name="Text 2"/>
           <p:cNvSpPr txBox="1"/>
           <p:nvPr/>
         </p:nvSpPr>
@@ -7051,7 +6867,7 @@
       </p:sp>
       <p:sp>
         <p:nvSpPr>
-          <p:cNvPr id="6" name="Text 4"/>
+          <p:cNvPr id="5" name="Text 3"/>
           <p:cNvSpPr txBox="1"/>
           <p:nvPr/>
         </p:nvSpPr>
@@ -7090,7 +6906,7 @@
       </p:sp>
       <p:sp>
         <p:nvSpPr>
-          <p:cNvPr id="7" name="Shape 5"/>
+          <p:cNvPr id="6" name="Shape 4"/>
           <p:cNvSpPr/>
           <p:nvPr/>
         </p:nvSpPr>
@@ -7103,19 +6919,14 @@
             <a:avLst/>
           </a:prstGeom>
           <a:solidFill>
-            <a:srgbClr val="FFFFFF"/>
+            <a:srgbClr val="E2E9EE"/>
           </a:solidFill>
-          <a:ln w="9525">
-            <a:solidFill>
-              <a:srgbClr val="E2E9EE"/>
-            </a:solidFill>
-            <a:prstDash val="solid"/>
-          </a:ln>
-        </p:spPr>
-      </p:sp>
-      <p:sp>
-        <p:nvSpPr>
-          <p:cNvPr id="8" name="Text 6"/>
+          <a:ln/>
+        </p:spPr>
+      </p:sp>
+      <p:sp>
+        <p:nvSpPr>
+          <p:cNvPr id="7" name="Text 5"/>
           <p:cNvSpPr txBox="1"/>
           <p:nvPr/>
         </p:nvSpPr>
@@ -7154,7 +6965,7 @@
       </p:sp>
       <p:sp>
         <p:nvSpPr>
-          <p:cNvPr id="9" name="Text 7"/>
+          <p:cNvPr id="8" name="Text 6"/>
           <p:cNvSpPr txBox="1"/>
           <p:nvPr/>
         </p:nvSpPr>
@@ -7196,7 +7007,7 @@
       </p:sp>
       <p:sp>
         <p:nvSpPr>
-          <p:cNvPr id="10" name="Shape 8"/>
+          <p:cNvPr id="9" name="Shape 7"/>
           <p:cNvSpPr/>
           <p:nvPr/>
         </p:nvSpPr>
@@ -7209,19 +7020,14 @@
             <a:avLst/>
           </a:prstGeom>
           <a:solidFill>
-            <a:srgbClr val="FFFFFF"/>
+            <a:srgbClr val="E2E9EE"/>
           </a:solidFill>
-          <a:ln w="9525">
-            <a:solidFill>
-              <a:srgbClr val="E2E9EE"/>
-            </a:solidFill>
-            <a:prstDash val="solid"/>
-          </a:ln>
-        </p:spPr>
-      </p:sp>
-      <p:sp>
-        <p:nvSpPr>
-          <p:cNvPr id="11" name="Text 9"/>
+          <a:ln/>
+        </p:spPr>
+      </p:sp>
+      <p:sp>
+        <p:nvSpPr>
+          <p:cNvPr id="10" name="Text 8"/>
           <p:cNvSpPr txBox="1"/>
           <p:nvPr/>
         </p:nvSpPr>
@@ -7260,7 +7066,7 @@
       </p:sp>
       <p:sp>
         <p:nvSpPr>
-          <p:cNvPr id="12" name="Text 10"/>
+          <p:cNvPr id="11" name="Text 9"/>
           <p:cNvSpPr txBox="1"/>
           <p:nvPr/>
         </p:nvSpPr>
@@ -7302,7 +7108,7 @@
       </p:sp>
       <p:sp>
         <p:nvSpPr>
-          <p:cNvPr id="13" name="Shape 11"/>
+          <p:cNvPr id="12" name="Shape 10"/>
           <p:cNvSpPr/>
           <p:nvPr/>
         </p:nvSpPr>
@@ -7315,19 +7121,14 @@
             <a:avLst/>
           </a:prstGeom>
           <a:solidFill>
-            <a:srgbClr val="FFFFFF"/>
+            <a:srgbClr val="E2E9EE"/>
           </a:solidFill>
-          <a:ln w="9525">
-            <a:solidFill>
-              <a:srgbClr val="E2E9EE"/>
-            </a:solidFill>
-            <a:prstDash val="solid"/>
-          </a:ln>
-        </p:spPr>
-      </p:sp>
-      <p:sp>
-        <p:nvSpPr>
-          <p:cNvPr id="14" name="Text 12"/>
+          <a:ln/>
+        </p:spPr>
+      </p:sp>
+      <p:sp>
+        <p:nvSpPr>
+          <p:cNvPr id="13" name="Text 11"/>
           <p:cNvSpPr txBox="1"/>
           <p:nvPr/>
         </p:nvSpPr>
@@ -7366,7 +7167,7 @@
       </p:sp>
       <p:sp>
         <p:nvSpPr>
-          <p:cNvPr id="15" name="Text 13"/>
+          <p:cNvPr id="14" name="Text 12"/>
           <p:cNvSpPr txBox="1"/>
           <p:nvPr/>
         </p:nvSpPr>
@@ -7408,7 +7209,7 @@
       </p:sp>
       <p:sp>
         <p:nvSpPr>
-          <p:cNvPr id="16" name="Shape 14"/>
+          <p:cNvPr id="15" name="Shape 13"/>
           <p:cNvSpPr/>
           <p:nvPr/>
         </p:nvSpPr>
@@ -7421,19 +7222,14 @@
             <a:avLst/>
           </a:prstGeom>
           <a:solidFill>
-            <a:srgbClr val="FFFFFF"/>
+            <a:srgbClr val="E2E9EE"/>
           </a:solidFill>
-          <a:ln w="9525">
-            <a:solidFill>
-              <a:srgbClr val="E2E9EE"/>
-            </a:solidFill>
-            <a:prstDash val="solid"/>
-          </a:ln>
-        </p:spPr>
-      </p:sp>
-      <p:sp>
-        <p:nvSpPr>
-          <p:cNvPr id="17" name="Text 15"/>
+          <a:ln/>
+        </p:spPr>
+      </p:sp>
+      <p:sp>
+        <p:nvSpPr>
+          <p:cNvPr id="16" name="Text 14"/>
           <p:cNvSpPr txBox="1"/>
           <p:nvPr/>
         </p:nvSpPr>
@@ -7472,7 +7268,7 @@
       </p:sp>
       <p:sp>
         <p:nvSpPr>
-          <p:cNvPr id="18" name="Text 16"/>
+          <p:cNvPr id="17" name="Text 15"/>
           <p:cNvSpPr txBox="1"/>
           <p:nvPr/>
         </p:nvSpPr>
@@ -7514,7 +7310,7 @@
       </p:sp>
       <p:sp>
         <p:nvSpPr>
-          <p:cNvPr id="19" name="Shape 17"/>
+          <p:cNvPr id="18" name="Shape 16"/>
           <p:cNvSpPr/>
           <p:nvPr/>
         </p:nvSpPr>
@@ -7527,19 +7323,14 @@
             <a:avLst/>
           </a:prstGeom>
           <a:solidFill>
-            <a:srgbClr val="FFFFFF"/>
+            <a:srgbClr val="E2E9EE"/>
           </a:solidFill>
-          <a:ln w="9525">
-            <a:solidFill>
-              <a:srgbClr val="E2E9EE"/>
-            </a:solidFill>
-            <a:prstDash val="solid"/>
-          </a:ln>
-        </p:spPr>
-      </p:sp>
-      <p:sp>
-        <p:nvSpPr>
-          <p:cNvPr id="20" name="Text 18"/>
+          <a:ln/>
+        </p:spPr>
+      </p:sp>
+      <p:sp>
+        <p:nvSpPr>
+          <p:cNvPr id="19" name="Text 17"/>
           <p:cNvSpPr txBox="1"/>
           <p:nvPr/>
         </p:nvSpPr>
@@ -7578,7 +7369,7 @@
       </p:sp>
       <p:sp>
         <p:nvSpPr>
-          <p:cNvPr id="21" name="Text 19"/>
+          <p:cNvPr id="20" name="Text 18"/>
           <p:cNvSpPr txBox="1"/>
           <p:nvPr/>
         </p:nvSpPr>
@@ -7620,7 +7411,7 @@
       </p:sp>
       <p:sp>
         <p:nvSpPr>
-          <p:cNvPr id="22" name="Shape 20"/>
+          <p:cNvPr id="21" name="Shape 19"/>
           <p:cNvSpPr/>
           <p:nvPr/>
         </p:nvSpPr>
@@ -7633,19 +7424,14 @@
             <a:avLst/>
           </a:prstGeom>
           <a:solidFill>
-            <a:srgbClr val="FFFFFF"/>
+            <a:srgbClr val="E2E9EE"/>
           </a:solidFill>
-          <a:ln w="9525">
-            <a:solidFill>
-              <a:srgbClr val="E2E9EE"/>
-            </a:solidFill>
-            <a:prstDash val="solid"/>
-          </a:ln>
-        </p:spPr>
-      </p:sp>
-      <p:sp>
-        <p:nvSpPr>
-          <p:cNvPr id="23" name="Text 21"/>
+          <a:ln/>
+        </p:spPr>
+      </p:sp>
+      <p:sp>
+        <p:nvSpPr>
+          <p:cNvPr id="22" name="Text 20"/>
           <p:cNvSpPr txBox="1"/>
           <p:nvPr/>
         </p:nvSpPr>
@@ -7684,7 +7470,7 @@
       </p:sp>
       <p:sp>
         <p:nvSpPr>
-          <p:cNvPr id="24" name="Text 22"/>
+          <p:cNvPr id="23" name="Text 21"/>
           <p:cNvSpPr txBox="1"/>
           <p:nvPr/>
         </p:nvSpPr>
@@ -7726,7 +7512,7 @@
       </p:sp>
       <p:sp>
         <p:nvSpPr>
-          <p:cNvPr id="25" name="Shape 23"/>
+          <p:cNvPr id="24" name="Shape 22"/>
           <p:cNvSpPr/>
           <p:nvPr/>
         </p:nvSpPr>
@@ -7739,19 +7525,14 @@
             <a:avLst/>
           </a:prstGeom>
           <a:solidFill>
-            <a:srgbClr val="FFFFFF"/>
+            <a:srgbClr val="E2E9EE"/>
           </a:solidFill>
-          <a:ln w="9525">
-            <a:solidFill>
-              <a:srgbClr val="E2E9EE"/>
-            </a:solidFill>
-            <a:prstDash val="solid"/>
-          </a:ln>
-        </p:spPr>
-      </p:sp>
-      <p:sp>
-        <p:nvSpPr>
-          <p:cNvPr id="26" name="Text 24"/>
+          <a:ln/>
+        </p:spPr>
+      </p:sp>
+      <p:sp>
+        <p:nvSpPr>
+          <p:cNvPr id="25" name="Text 23"/>
           <p:cNvSpPr txBox="1"/>
           <p:nvPr/>
         </p:nvSpPr>
@@ -7790,7 +7571,7 @@
       </p:sp>
       <p:sp>
         <p:nvSpPr>
-          <p:cNvPr id="27" name="Text 25"/>
+          <p:cNvPr id="26" name="Text 24"/>
           <p:cNvSpPr txBox="1"/>
           <p:nvPr/>
         </p:nvSpPr>
@@ -7832,7 +7613,7 @@
       </p:sp>
       <p:sp>
         <p:nvSpPr>
-          <p:cNvPr id="28" name="Shape 26"/>
+          <p:cNvPr id="27" name="Shape 25"/>
           <p:cNvSpPr/>
           <p:nvPr/>
         </p:nvSpPr>
@@ -7845,19 +7626,14 @@
             <a:avLst/>
           </a:prstGeom>
           <a:solidFill>
-            <a:srgbClr val="FFFFFF"/>
+            <a:srgbClr val="E2E9EE"/>
           </a:solidFill>
-          <a:ln w="9525">
-            <a:solidFill>
-              <a:srgbClr val="E2E9EE"/>
-            </a:solidFill>
-            <a:prstDash val="solid"/>
-          </a:ln>
-        </p:spPr>
-      </p:sp>
-      <p:sp>
-        <p:nvSpPr>
-          <p:cNvPr id="29" name="Text 27"/>
+          <a:ln/>
+        </p:spPr>
+      </p:sp>
+      <p:sp>
+        <p:nvSpPr>
+          <p:cNvPr id="28" name="Text 26"/>
           <p:cNvSpPr txBox="1"/>
           <p:nvPr/>
         </p:nvSpPr>
@@ -7896,7 +7672,7 @@
       </p:sp>
       <p:sp>
         <p:nvSpPr>
-          <p:cNvPr id="30" name="Text 28"/>
+          <p:cNvPr id="29" name="Text 27"/>
           <p:cNvSpPr txBox="1"/>
           <p:nvPr/>
         </p:nvSpPr>
@@ -7938,7 +7714,7 @@
       </p:sp>
       <p:sp>
         <p:nvSpPr>
-          <p:cNvPr id="31" name="Shape 29"/>
+          <p:cNvPr id="30" name="Shape 28"/>
           <p:cNvSpPr/>
           <p:nvPr/>
         </p:nvSpPr>
@@ -7958,7 +7734,7 @@
       </p:sp>
       <p:sp>
         <p:nvSpPr>
-          <p:cNvPr id="32" name="Text 30"/>
+          <p:cNvPr id="31" name="Text 29"/>
           <p:cNvSpPr txBox="1"/>
           <p:nvPr/>
         </p:nvSpPr>
@@ -7997,7 +7773,7 @@
       </p:sp>
       <p:sp>
         <p:nvSpPr>
-          <p:cNvPr id="33" name="Text 31"/>
+          <p:cNvPr id="32" name="Text 30"/>
           <p:cNvSpPr txBox="1"/>
           <p:nvPr/>
         </p:nvSpPr>
@@ -8036,7 +7812,7 @@
       </p:sp>
       <p:sp>
         <p:nvSpPr>
-          <p:cNvPr id="34" name="Shape 32"/>
+          <p:cNvPr id="33" name="Shape 31"/>
           <p:cNvSpPr/>
           <p:nvPr/>
         </p:nvSpPr>
@@ -8061,7 +7837,7 @@
       </p:sp>
       <p:sp>
         <p:nvSpPr>
-          <p:cNvPr id="35" name="Text 33"/>
+          <p:cNvPr id="34" name="Text 32"/>
           <p:cNvSpPr txBox="1"/>
           <p:nvPr/>
         </p:nvSpPr>
@@ -8100,7 +7876,7 @@
       </p:sp>
       <p:sp>
         <p:nvSpPr>
-          <p:cNvPr id="36" name="Shape 34"/>
+          <p:cNvPr id="35" name="Shape 33"/>
           <p:cNvSpPr/>
           <p:nvPr/>
         </p:nvSpPr>
@@ -8125,7 +7901,7 @@
       </p:sp>
       <p:sp>
         <p:nvSpPr>
-          <p:cNvPr id="37" name="Text 35"/>
+          <p:cNvPr id="36" name="Text 34"/>
           <p:cNvSpPr txBox="1"/>
           <p:nvPr/>
         </p:nvSpPr>
@@ -8164,7 +7940,7 @@
       </p:sp>
       <p:sp>
         <p:nvSpPr>
-          <p:cNvPr id="38" name="Shape 36"/>
+          <p:cNvPr id="37" name="Shape 35"/>
           <p:cNvSpPr/>
           <p:nvPr/>
         </p:nvSpPr>
@@ -8189,7 +7965,7 @@
       </p:sp>
       <p:sp>
         <p:nvSpPr>
-          <p:cNvPr id="39" name="Text 37"/>
+          <p:cNvPr id="38" name="Text 36"/>
           <p:cNvSpPr txBox="1"/>
           <p:nvPr/>
         </p:nvSpPr>
@@ -8228,7 +8004,7 @@
       </p:sp>
       <p:sp>
         <p:nvSpPr>
-          <p:cNvPr id="40" name="Shape 38"/>
+          <p:cNvPr id="39" name="Shape 37"/>
           <p:cNvSpPr/>
           <p:nvPr/>
         </p:nvSpPr>
@@ -8253,7 +8029,7 @@
       </p:sp>
       <p:sp>
         <p:nvSpPr>
-          <p:cNvPr id="41" name="Text 39"/>
+          <p:cNvPr id="40" name="Text 38"/>
           <p:cNvSpPr txBox="1"/>
           <p:nvPr/>
         </p:nvSpPr>
@@ -8292,7 +8068,7 @@
       </p:sp>
       <p:sp>
         <p:nvSpPr>
-          <p:cNvPr id="42" name="Text 40"/>
+          <p:cNvPr id="41" name="Text 39"/>
           <p:cNvSpPr txBox="1"/>
           <p:nvPr/>
         </p:nvSpPr>
@@ -8334,7 +8110,7 @@
       </p:sp>
       <p:sp>
         <p:nvSpPr>
-          <p:cNvPr id="43" name="Text 41"/>
+          <p:cNvPr id="42" name="Text 40"/>
           <p:cNvSpPr txBox="1"/>
           <p:nvPr/>
         </p:nvSpPr>
@@ -8373,7 +8149,7 @@
       </p:sp>
       <p:sp>
         <p:nvSpPr>
-          <p:cNvPr id="44" name="Text 42"/>
+          <p:cNvPr id="43" name="Text 41"/>
           <p:cNvSpPr txBox="1"/>
           <p:nvPr/>
         </p:nvSpPr>
@@ -8444,36 +8220,13 @@
       </p:grpSpPr>
       <p:sp>
         <p:nvSpPr>
-          <p:cNvPr id="2" name="Shape 0"/>
-          <p:cNvSpPr/>
-          <p:nvPr/>
-        </p:nvSpPr>
-        <p:spPr>
-          <a:xfrm>
-            <a:off x="777240" y="580644"/>
-            <a:ext cx="237744" cy="0"/>
-          </a:xfrm>
-          <a:prstGeom prst="line">
-            <a:avLst/>
-          </a:prstGeom>
-          <a:noFill/>
-          <a:ln w="12700">
-            <a:solidFill>
-              <a:srgbClr val="11676A"/>
-            </a:solidFill>
-            <a:prstDash val="solid"/>
-          </a:ln>
-        </p:spPr>
-      </p:sp>
-      <p:sp>
-        <p:nvSpPr>
-          <p:cNvPr id="3" name="Text 1"/>
-          <p:cNvSpPr txBox="1"/>
-          <p:nvPr/>
-        </p:nvSpPr>
-        <p:spPr>
-          <a:xfrm>
-            <a:off x="1106424" y="461772"/>
+          <p:cNvPr id="2" name="Text 0"/>
+          <p:cNvSpPr txBox="1"/>
+          <p:nvPr/>
+        </p:nvSpPr>
+        <p:spPr>
+          <a:xfrm>
+            <a:off x="777240" y="461772"/>
             <a:ext cx="5486400" cy="237744"/>
           </a:xfrm>
           <a:prstGeom prst="rect">
@@ -8506,7 +8259,7 @@
       </p:sp>
       <p:sp>
         <p:nvSpPr>
-          <p:cNvPr id="4" name="Text 2"/>
+          <p:cNvPr id="3" name="Text 1"/>
           <p:cNvSpPr txBox="1"/>
           <p:nvPr/>
         </p:nvSpPr>
@@ -8548,7 +8301,7 @@
       </p:sp>
       <p:sp>
         <p:nvSpPr>
-          <p:cNvPr id="5" name="Text 3"/>
+          <p:cNvPr id="4" name="Text 2"/>
           <p:cNvSpPr txBox="1"/>
           <p:nvPr/>
         </p:nvSpPr>
@@ -8590,6 +8343,26 @@
       </p:sp>
       <p:sp>
         <p:nvSpPr>
+          <p:cNvPr id="5" name="Shape 3"/>
+          <p:cNvSpPr/>
+          <p:nvPr/>
+        </p:nvSpPr>
+        <p:spPr>
+          <a:xfrm>
+            <a:off x="612648" y="1990852"/>
+            <a:ext cx="10966399" cy="365760"/>
+          </a:xfrm>
+          <a:prstGeom prst="rect">
+            <a:avLst/>
+          </a:prstGeom>
+          <a:solidFill>
+            <a:srgbClr val="F7F8F7"/>
+          </a:solidFill>
+          <a:ln/>
+        </p:spPr>
+      </p:sp>
+      <p:sp>
+        <p:nvSpPr>
           <p:cNvPr id="6" name="Text 4"/>
           <p:cNvSpPr txBox="1"/>
           <p:nvPr/>
@@ -8746,36 +8519,13 @@
       </p:sp>
       <p:sp>
         <p:nvSpPr>
-          <p:cNvPr id="10" name="Shape 8"/>
-          <p:cNvSpPr/>
-          <p:nvPr/>
-        </p:nvSpPr>
-        <p:spPr>
-          <a:xfrm>
-            <a:off x="777240" y="2292604"/>
-            <a:ext cx="10637215" cy="0"/>
-          </a:xfrm>
-          <a:prstGeom prst="line">
-            <a:avLst/>
-          </a:prstGeom>
-          <a:noFill/>
-          <a:ln w="12700">
-            <a:solidFill>
-              <a:srgbClr val="11676A"/>
-            </a:solidFill>
-            <a:prstDash val="solid"/>
-          </a:ln>
-        </p:spPr>
-      </p:sp>
-      <p:sp>
-        <p:nvSpPr>
-          <p:cNvPr id="11" name="Text 9"/>
-          <p:cNvSpPr txBox="1"/>
-          <p:nvPr/>
-        </p:nvSpPr>
-        <p:spPr>
-          <a:xfrm>
-            <a:off x="777240" y="2475484"/>
+          <p:cNvPr id="10" name="Text 8"/>
+          <p:cNvSpPr txBox="1"/>
+          <p:nvPr/>
+        </p:nvSpPr>
+        <p:spPr>
+          <a:xfrm>
+            <a:off x="777240" y="2585212"/>
             <a:ext cx="2834640" cy="237744"/>
           </a:xfrm>
           <a:prstGeom prst="rect">
@@ -8808,13 +8558,13 @@
       </p:sp>
       <p:sp>
         <p:nvSpPr>
-          <p:cNvPr id="12" name="Text 10"/>
-          <p:cNvSpPr txBox="1"/>
-          <p:nvPr/>
-        </p:nvSpPr>
-        <p:spPr>
-          <a:xfrm>
-            <a:off x="777240" y="2731516"/>
+          <p:cNvPr id="11" name="Text 9"/>
+          <p:cNvSpPr txBox="1"/>
+          <p:nvPr/>
+        </p:nvSpPr>
+        <p:spPr>
+          <a:xfrm>
+            <a:off x="777240" y="2841244"/>
             <a:ext cx="2834640" cy="365760"/>
           </a:xfrm>
           <a:prstGeom prst="rect">
@@ -8850,13 +8600,13 @@
       </p:sp>
       <p:sp>
         <p:nvSpPr>
-          <p:cNvPr id="13" name="Text 11"/>
-          <p:cNvSpPr txBox="1"/>
-          <p:nvPr/>
-        </p:nvSpPr>
-        <p:spPr>
-          <a:xfrm>
-            <a:off x="3840480" y="2502916"/>
+          <p:cNvPr id="12" name="Text 10"/>
+          <p:cNvSpPr txBox="1"/>
+          <p:nvPr/>
+        </p:nvSpPr>
+        <p:spPr>
+          <a:xfrm>
+            <a:off x="3840480" y="2612644"/>
             <a:ext cx="2788920" cy="548640"/>
           </a:xfrm>
           <a:prstGeom prst="rect">
@@ -8892,13 +8642,13 @@
       </p:sp>
       <p:sp>
         <p:nvSpPr>
-          <p:cNvPr id="14" name="Text 12"/>
-          <p:cNvSpPr txBox="1"/>
-          <p:nvPr/>
-        </p:nvSpPr>
-        <p:spPr>
-          <a:xfrm>
-            <a:off x="6766560" y="2502916"/>
+          <p:cNvPr id="13" name="Text 11"/>
+          <p:cNvSpPr txBox="1"/>
+          <p:nvPr/>
+        </p:nvSpPr>
+        <p:spPr>
+          <a:xfrm>
+            <a:off x="6766560" y="2612644"/>
             <a:ext cx="2057400" cy="502920"/>
           </a:xfrm>
           <a:prstGeom prst="rect">
@@ -8954,13 +8704,13 @@
       </p:sp>
       <p:sp>
         <p:nvSpPr>
-          <p:cNvPr id="15" name="Text 13"/>
-          <p:cNvSpPr txBox="1"/>
-          <p:nvPr/>
-        </p:nvSpPr>
-        <p:spPr>
-          <a:xfrm>
-            <a:off x="8961120" y="2502916"/>
+          <p:cNvPr id="14" name="Text 12"/>
+          <p:cNvSpPr txBox="1"/>
+          <p:nvPr/>
+        </p:nvSpPr>
+        <p:spPr>
+          <a:xfrm>
+            <a:off x="8961120" y="2612644"/>
             <a:ext cx="2450592" cy="548640"/>
           </a:xfrm>
           <a:prstGeom prst="rect">
@@ -8996,13 +8746,13 @@
       </p:sp>
       <p:sp>
         <p:nvSpPr>
-          <p:cNvPr id="16" name="Text 14"/>
-          <p:cNvSpPr txBox="1"/>
-          <p:nvPr/>
-        </p:nvSpPr>
-        <p:spPr>
-          <a:xfrm>
-            <a:off x="777240" y="3252724"/>
+          <p:cNvPr id="15" name="Text 13"/>
+          <p:cNvSpPr txBox="1"/>
+          <p:nvPr/>
+        </p:nvSpPr>
+        <p:spPr>
+          <a:xfrm>
+            <a:off x="777240" y="3335020"/>
             <a:ext cx="2834640" cy="237744"/>
           </a:xfrm>
           <a:prstGeom prst="rect">
@@ -9035,13 +8785,13 @@
       </p:sp>
       <p:sp>
         <p:nvSpPr>
-          <p:cNvPr id="17" name="Text 15"/>
-          <p:cNvSpPr txBox="1"/>
-          <p:nvPr/>
-        </p:nvSpPr>
-        <p:spPr>
-          <a:xfrm>
-            <a:off x="777240" y="3508756"/>
+          <p:cNvPr id="16" name="Text 14"/>
+          <p:cNvSpPr txBox="1"/>
+          <p:nvPr/>
+        </p:nvSpPr>
+        <p:spPr>
+          <a:xfrm>
+            <a:off x="777240" y="3591052"/>
             <a:ext cx="2834640" cy="365760"/>
           </a:xfrm>
           <a:prstGeom prst="rect">
@@ -9077,13 +8827,13 @@
       </p:sp>
       <p:sp>
         <p:nvSpPr>
-          <p:cNvPr id="18" name="Text 16"/>
-          <p:cNvSpPr txBox="1"/>
-          <p:nvPr/>
-        </p:nvSpPr>
-        <p:spPr>
-          <a:xfrm>
-            <a:off x="3840480" y="3280156"/>
+          <p:cNvPr id="17" name="Text 15"/>
+          <p:cNvSpPr txBox="1"/>
+          <p:nvPr/>
+        </p:nvSpPr>
+        <p:spPr>
+          <a:xfrm>
+            <a:off x="3840480" y="3362452"/>
             <a:ext cx="2788920" cy="548640"/>
           </a:xfrm>
           <a:prstGeom prst="rect">
@@ -9119,13 +8869,13 @@
       </p:sp>
       <p:sp>
         <p:nvSpPr>
-          <p:cNvPr id="19" name="Text 17"/>
-          <p:cNvSpPr txBox="1"/>
-          <p:nvPr/>
-        </p:nvSpPr>
-        <p:spPr>
-          <a:xfrm>
-            <a:off x="6766560" y="3280156"/>
+          <p:cNvPr id="18" name="Text 16"/>
+          <p:cNvSpPr txBox="1"/>
+          <p:nvPr/>
+        </p:nvSpPr>
+        <p:spPr>
+          <a:xfrm>
+            <a:off x="6766560" y="3362452"/>
             <a:ext cx="2057400" cy="502920"/>
           </a:xfrm>
           <a:prstGeom prst="rect">
@@ -9181,13 +8931,13 @@
       </p:sp>
       <p:sp>
         <p:nvSpPr>
-          <p:cNvPr id="20" name="Text 18"/>
-          <p:cNvSpPr txBox="1"/>
-          <p:nvPr/>
-        </p:nvSpPr>
-        <p:spPr>
-          <a:xfrm>
-            <a:off x="8961120" y="3280156"/>
+          <p:cNvPr id="19" name="Text 17"/>
+          <p:cNvSpPr txBox="1"/>
+          <p:nvPr/>
+        </p:nvSpPr>
+        <p:spPr>
+          <a:xfrm>
+            <a:off x="8961120" y="3362452"/>
             <a:ext cx="2450592" cy="548640"/>
           </a:xfrm>
           <a:prstGeom prst="rect">
@@ -9223,13 +8973,13 @@
       </p:sp>
       <p:sp>
         <p:nvSpPr>
-          <p:cNvPr id="21" name="Text 19"/>
-          <p:cNvSpPr txBox="1"/>
-          <p:nvPr/>
-        </p:nvSpPr>
-        <p:spPr>
-          <a:xfrm>
-            <a:off x="777240" y="4029964"/>
+          <p:cNvPr id="20" name="Text 18"/>
+          <p:cNvSpPr txBox="1"/>
+          <p:nvPr/>
+        </p:nvSpPr>
+        <p:spPr>
+          <a:xfrm>
+            <a:off x="777240" y="4084828"/>
             <a:ext cx="2834640" cy="237744"/>
           </a:xfrm>
           <a:prstGeom prst="rect">
@@ -9262,13 +9012,13 @@
       </p:sp>
       <p:sp>
         <p:nvSpPr>
-          <p:cNvPr id="22" name="Text 20"/>
-          <p:cNvSpPr txBox="1"/>
-          <p:nvPr/>
-        </p:nvSpPr>
-        <p:spPr>
-          <a:xfrm>
-            <a:off x="777240" y="4285996"/>
+          <p:cNvPr id="21" name="Text 19"/>
+          <p:cNvSpPr txBox="1"/>
+          <p:nvPr/>
+        </p:nvSpPr>
+        <p:spPr>
+          <a:xfrm>
+            <a:off x="777240" y="4340860"/>
             <a:ext cx="2834640" cy="365760"/>
           </a:xfrm>
           <a:prstGeom prst="rect">
@@ -9304,13 +9054,13 @@
       </p:sp>
       <p:sp>
         <p:nvSpPr>
-          <p:cNvPr id="23" name="Text 21"/>
-          <p:cNvSpPr txBox="1"/>
-          <p:nvPr/>
-        </p:nvSpPr>
-        <p:spPr>
-          <a:xfrm>
-            <a:off x="3840480" y="4057396"/>
+          <p:cNvPr id="22" name="Text 20"/>
+          <p:cNvSpPr txBox="1"/>
+          <p:nvPr/>
+        </p:nvSpPr>
+        <p:spPr>
+          <a:xfrm>
+            <a:off x="3840480" y="4112260"/>
             <a:ext cx="2788920" cy="548640"/>
           </a:xfrm>
           <a:prstGeom prst="rect">
@@ -9346,13 +9096,13 @@
       </p:sp>
       <p:sp>
         <p:nvSpPr>
-          <p:cNvPr id="24" name="Text 22"/>
-          <p:cNvSpPr txBox="1"/>
-          <p:nvPr/>
-        </p:nvSpPr>
-        <p:spPr>
-          <a:xfrm>
-            <a:off x="6766560" y="4057396"/>
+          <p:cNvPr id="23" name="Text 21"/>
+          <p:cNvSpPr txBox="1"/>
+          <p:nvPr/>
+        </p:nvSpPr>
+        <p:spPr>
+          <a:xfrm>
+            <a:off x="6766560" y="4112260"/>
             <a:ext cx="2057400" cy="502920"/>
           </a:xfrm>
           <a:prstGeom prst="rect">
@@ -9408,13 +9158,13 @@
       </p:sp>
       <p:sp>
         <p:nvSpPr>
-          <p:cNvPr id="25" name="Text 23"/>
-          <p:cNvSpPr txBox="1"/>
-          <p:nvPr/>
-        </p:nvSpPr>
-        <p:spPr>
-          <a:xfrm>
-            <a:off x="8961120" y="4057396"/>
+          <p:cNvPr id="24" name="Text 22"/>
+          <p:cNvSpPr txBox="1"/>
+          <p:nvPr/>
+        </p:nvSpPr>
+        <p:spPr>
+          <a:xfrm>
+            <a:off x="8961120" y="4112260"/>
             <a:ext cx="2450592" cy="548640"/>
           </a:xfrm>
           <a:prstGeom prst="rect">
@@ -9450,13 +9200,13 @@
       </p:sp>
       <p:sp>
         <p:nvSpPr>
-          <p:cNvPr id="26" name="Text 24"/>
-          <p:cNvSpPr txBox="1"/>
-          <p:nvPr/>
-        </p:nvSpPr>
-        <p:spPr>
-          <a:xfrm>
-            <a:off x="777240" y="4807204"/>
+          <p:cNvPr id="25" name="Text 23"/>
+          <p:cNvSpPr txBox="1"/>
+          <p:nvPr/>
+        </p:nvSpPr>
+        <p:spPr>
+          <a:xfrm>
+            <a:off x="777240" y="4834636"/>
             <a:ext cx="2834640" cy="237744"/>
           </a:xfrm>
           <a:prstGeom prst="rect">
@@ -9489,13 +9239,13 @@
       </p:sp>
       <p:sp>
         <p:nvSpPr>
-          <p:cNvPr id="27" name="Text 25"/>
-          <p:cNvSpPr txBox="1"/>
-          <p:nvPr/>
-        </p:nvSpPr>
-        <p:spPr>
-          <a:xfrm>
-            <a:off x="777240" y="5063236"/>
+          <p:cNvPr id="26" name="Text 24"/>
+          <p:cNvSpPr txBox="1"/>
+          <p:nvPr/>
+        </p:nvSpPr>
+        <p:spPr>
+          <a:xfrm>
+            <a:off x="777240" y="5090668"/>
             <a:ext cx="2834640" cy="365760"/>
           </a:xfrm>
           <a:prstGeom prst="rect">
@@ -9531,13 +9281,13 @@
       </p:sp>
       <p:sp>
         <p:nvSpPr>
-          <p:cNvPr id="28" name="Text 26"/>
-          <p:cNvSpPr txBox="1"/>
-          <p:nvPr/>
-        </p:nvSpPr>
-        <p:spPr>
-          <a:xfrm>
-            <a:off x="3840480" y="4834636"/>
+          <p:cNvPr id="27" name="Text 25"/>
+          <p:cNvSpPr txBox="1"/>
+          <p:nvPr/>
+        </p:nvSpPr>
+        <p:spPr>
+          <a:xfrm>
+            <a:off x="3840480" y="4862068"/>
             <a:ext cx="2788920" cy="548640"/>
           </a:xfrm>
           <a:prstGeom prst="rect">
@@ -9573,13 +9323,13 @@
       </p:sp>
       <p:sp>
         <p:nvSpPr>
-          <p:cNvPr id="29" name="Text 27"/>
-          <p:cNvSpPr txBox="1"/>
-          <p:nvPr/>
-        </p:nvSpPr>
-        <p:spPr>
-          <a:xfrm>
-            <a:off x="6766560" y="4834636"/>
+          <p:cNvPr id="28" name="Text 26"/>
+          <p:cNvSpPr txBox="1"/>
+          <p:nvPr/>
+        </p:nvSpPr>
+        <p:spPr>
+          <a:xfrm>
+            <a:off x="6766560" y="4862068"/>
             <a:ext cx="2057400" cy="502920"/>
           </a:xfrm>
           <a:prstGeom prst="rect">
@@ -9635,13 +9385,13 @@
       </p:sp>
       <p:sp>
         <p:nvSpPr>
-          <p:cNvPr id="30" name="Text 28"/>
-          <p:cNvSpPr txBox="1"/>
-          <p:nvPr/>
-        </p:nvSpPr>
-        <p:spPr>
-          <a:xfrm>
-            <a:off x="8961120" y="4834636"/>
+          <p:cNvPr id="29" name="Text 27"/>
+          <p:cNvSpPr txBox="1"/>
+          <p:nvPr/>
+        </p:nvSpPr>
+        <p:spPr>
+          <a:xfrm>
+            <a:off x="8961120" y="4862068"/>
             <a:ext cx="2450592" cy="548640"/>
           </a:xfrm>
           <a:prstGeom prst="rect">
@@ -9677,7 +9427,7 @@
       </p:sp>
       <p:sp>
         <p:nvSpPr>
-          <p:cNvPr id="31" name="Text 29"/>
+          <p:cNvPr id="30" name="Text 28"/>
           <p:cNvSpPr txBox="1"/>
           <p:nvPr/>
         </p:nvSpPr>
@@ -9716,7 +9466,7 @@
       </p:sp>
       <p:sp>
         <p:nvSpPr>
-          <p:cNvPr id="32" name="Text 30"/>
+          <p:cNvPr id="31" name="Text 29"/>
           <p:cNvSpPr txBox="1"/>
           <p:nvPr/>
         </p:nvSpPr>
@@ -9758,7 +9508,7 @@
       </p:sp>
       <p:sp>
         <p:nvSpPr>
-          <p:cNvPr id="33" name="Text 31"/>
+          <p:cNvPr id="32" name="Text 30"/>
           <p:cNvSpPr txBox="1"/>
           <p:nvPr/>
         </p:nvSpPr>
@@ -9800,7 +9550,7 @@
       </p:sp>
       <p:sp>
         <p:nvSpPr>
-          <p:cNvPr id="34" name="Text 32"/>
+          <p:cNvPr id="33" name="Text 31"/>
           <p:cNvSpPr txBox="1"/>
           <p:nvPr/>
         </p:nvSpPr>
@@ -9862,7 +9612,7 @@
       </p:sp>
       <p:sp>
         <p:nvSpPr>
-          <p:cNvPr id="35" name="Text 33"/>
+          <p:cNvPr id="34" name="Text 32"/>
           <p:cNvSpPr txBox="1"/>
           <p:nvPr/>
         </p:nvSpPr>
@@ -9904,7 +9654,7 @@
       </p:sp>
       <p:sp>
         <p:nvSpPr>
-          <p:cNvPr id="36" name="Text 34"/>
+          <p:cNvPr id="35" name="Text 33"/>
           <p:cNvSpPr txBox="1"/>
           <p:nvPr/>
         </p:nvSpPr>
@@ -9943,7 +9693,7 @@
       </p:sp>
       <p:sp>
         <p:nvSpPr>
-          <p:cNvPr id="37" name="Text 35"/>
+          <p:cNvPr id="36" name="Text 34"/>
           <p:cNvSpPr txBox="1"/>
           <p:nvPr/>
         </p:nvSpPr>
@@ -10014,36 +9764,13 @@
       </p:grpSpPr>
       <p:sp>
         <p:nvSpPr>
-          <p:cNvPr id="2" name="Shape 0"/>
-          <p:cNvSpPr/>
-          <p:nvPr/>
-        </p:nvSpPr>
-        <p:spPr>
-          <a:xfrm>
-            <a:off x="777240" y="580644"/>
-            <a:ext cx="237744" cy="0"/>
-          </a:xfrm>
-          <a:prstGeom prst="line">
-            <a:avLst/>
-          </a:prstGeom>
-          <a:noFill/>
-          <a:ln w="12700">
-            <a:solidFill>
-              <a:srgbClr val="11676A"/>
-            </a:solidFill>
-            <a:prstDash val="solid"/>
-          </a:ln>
-        </p:spPr>
-      </p:sp>
-      <p:sp>
-        <p:nvSpPr>
-          <p:cNvPr id="3" name="Text 1"/>
-          <p:cNvSpPr txBox="1"/>
-          <p:nvPr/>
-        </p:nvSpPr>
-        <p:spPr>
-          <a:xfrm>
-            <a:off x="1106424" y="461772"/>
+          <p:cNvPr id="2" name="Text 0"/>
+          <p:cNvSpPr txBox="1"/>
+          <p:nvPr/>
+        </p:nvSpPr>
+        <p:spPr>
+          <a:xfrm>
+            <a:off x="777240" y="461772"/>
             <a:ext cx="5486400" cy="237744"/>
           </a:xfrm>
           <a:prstGeom prst="rect">
@@ -10076,7 +9803,7 @@
       </p:sp>
       <p:sp>
         <p:nvSpPr>
-          <p:cNvPr id="4" name="Text 2"/>
+          <p:cNvPr id="3" name="Text 1"/>
           <p:cNvSpPr txBox="1"/>
           <p:nvPr/>
         </p:nvSpPr>
@@ -10118,7 +9845,7 @@
       </p:sp>
       <p:sp>
         <p:nvSpPr>
-          <p:cNvPr id="5" name="Text 3"/>
+          <p:cNvPr id="4" name="Text 2"/>
           <p:cNvSpPr txBox="1"/>
           <p:nvPr/>
         </p:nvSpPr>
@@ -10160,7 +9887,7 @@
       </p:sp>
       <p:pic>
         <p:nvPicPr>
-          <p:cNvPr id="6" name="Image 0" descr="./assets/fig-cloud.jpg">    </p:cNvPr>
+          <p:cNvPr id="5" name="Image 0" descr="./assets/fig-cloud.jpg">    </p:cNvPr>
           <p:cNvPicPr>
             <a:picLocks noChangeAspect="1"/>
           </p:cNvPicPr>
@@ -10184,7 +9911,7 @@
       </p:pic>
       <p:sp>
         <p:nvSpPr>
-          <p:cNvPr id="7" name="Text 4"/>
+          <p:cNvPr id="6" name="Text 3"/>
           <p:cNvSpPr txBox="1"/>
           <p:nvPr/>
         </p:nvSpPr>
@@ -10223,7 +9950,7 @@
       </p:sp>
       <p:sp>
         <p:nvSpPr>
-          <p:cNvPr id="8" name="Text 5"/>
+          <p:cNvPr id="7" name="Text 4"/>
           <p:cNvSpPr txBox="1"/>
           <p:nvPr/>
         </p:nvSpPr>
@@ -10262,7 +9989,7 @@
       </p:sp>
       <p:sp>
         <p:nvSpPr>
-          <p:cNvPr id="9" name="Text 6"/>
+          <p:cNvPr id="8" name="Text 5"/>
           <p:cNvSpPr txBox="1"/>
           <p:nvPr/>
         </p:nvSpPr>
@@ -10301,7 +10028,7 @@
       </p:sp>
       <p:sp>
         <p:nvSpPr>
-          <p:cNvPr id="10" name="Text 7"/>
+          <p:cNvPr id="9" name="Text 6"/>
           <p:cNvSpPr txBox="1"/>
           <p:nvPr/>
         </p:nvSpPr>
@@ -10340,7 +10067,7 @@
       </p:sp>
       <p:sp>
         <p:nvSpPr>
-          <p:cNvPr id="11" name="Text 8"/>
+          <p:cNvPr id="10" name="Text 7"/>
           <p:cNvSpPr txBox="1"/>
           <p:nvPr/>
         </p:nvSpPr>
@@ -10379,7 +10106,7 @@
       </p:sp>
       <p:sp>
         <p:nvSpPr>
-          <p:cNvPr id="12" name="Text 9"/>
+          <p:cNvPr id="11" name="Text 8"/>
           <p:cNvSpPr txBox="1"/>
           <p:nvPr/>
         </p:nvSpPr>
@@ -10418,7 +10145,7 @@
       </p:sp>
       <p:sp>
         <p:nvSpPr>
-          <p:cNvPr id="13" name="Text 10"/>
+          <p:cNvPr id="12" name="Text 9"/>
           <p:cNvSpPr txBox="1"/>
           <p:nvPr/>
         </p:nvSpPr>
@@ -10457,7 +10184,7 @@
       </p:sp>
       <p:sp>
         <p:nvSpPr>
-          <p:cNvPr id="14" name="Text 11"/>
+          <p:cNvPr id="13" name="Text 10"/>
           <p:cNvSpPr txBox="1"/>
           <p:nvPr/>
         </p:nvSpPr>
@@ -10496,7 +10223,7 @@
       </p:sp>
       <p:sp>
         <p:nvSpPr>
-          <p:cNvPr id="15" name="Text 12"/>
+          <p:cNvPr id="14" name="Text 11"/>
           <p:cNvSpPr txBox="1"/>
           <p:nvPr/>
         </p:nvSpPr>
@@ -10535,7 +10262,7 @@
       </p:sp>
       <p:sp>
         <p:nvSpPr>
-          <p:cNvPr id="16" name="Text 13"/>
+          <p:cNvPr id="15" name="Text 12"/>
           <p:cNvSpPr txBox="1"/>
           <p:nvPr/>
         </p:nvSpPr>
@@ -10574,7 +10301,7 @@
       </p:sp>
       <p:sp>
         <p:nvSpPr>
-          <p:cNvPr id="17" name="Text 14"/>
+          <p:cNvPr id="16" name="Text 13"/>
           <p:cNvSpPr txBox="1"/>
           <p:nvPr/>
         </p:nvSpPr>
@@ -10613,7 +10340,7 @@
       </p:sp>
       <p:sp>
         <p:nvSpPr>
-          <p:cNvPr id="18" name="Text 15"/>
+          <p:cNvPr id="17" name="Text 14"/>
           <p:cNvSpPr txBox="1"/>
           <p:nvPr/>
         </p:nvSpPr>
@@ -10652,7 +10379,7 @@
       </p:sp>
       <p:sp>
         <p:nvSpPr>
-          <p:cNvPr id="19" name="Text 16"/>
+          <p:cNvPr id="18" name="Text 15"/>
           <p:cNvSpPr txBox="1"/>
           <p:nvPr/>
         </p:nvSpPr>
@@ -10691,7 +10418,7 @@
       </p:sp>
       <p:sp>
         <p:nvSpPr>
-          <p:cNvPr id="20" name="Text 17"/>
+          <p:cNvPr id="19" name="Text 16"/>
           <p:cNvSpPr txBox="1"/>
           <p:nvPr/>
         </p:nvSpPr>
@@ -10730,7 +10457,7 @@
       </p:sp>
       <p:sp>
         <p:nvSpPr>
-          <p:cNvPr id="21" name="Text 18"/>
+          <p:cNvPr id="20" name="Text 17"/>
           <p:cNvSpPr txBox="1"/>
           <p:nvPr/>
         </p:nvSpPr>
@@ -10769,7 +10496,7 @@
       </p:sp>
       <p:sp>
         <p:nvSpPr>
-          <p:cNvPr id="22" name="Text 19"/>
+          <p:cNvPr id="21" name="Text 18"/>
           <p:cNvSpPr txBox="1"/>
           <p:nvPr/>
         </p:nvSpPr>
@@ -10808,7 +10535,7 @@
       </p:sp>
       <p:sp>
         <p:nvSpPr>
-          <p:cNvPr id="23" name="Text 20"/>
+          <p:cNvPr id="22" name="Text 19"/>
           <p:cNvSpPr txBox="1"/>
           <p:nvPr/>
         </p:nvSpPr>
@@ -10847,7 +10574,7 @@
       </p:sp>
       <p:sp>
         <p:nvSpPr>
-          <p:cNvPr id="24" name="Text 21"/>
+          <p:cNvPr id="23" name="Text 20"/>
           <p:cNvSpPr txBox="1"/>
           <p:nvPr/>
         </p:nvSpPr>
@@ -10886,7 +10613,7 @@
       </p:sp>
       <p:sp>
         <p:nvSpPr>
-          <p:cNvPr id="25" name="Text 22"/>
+          <p:cNvPr id="24" name="Text 21"/>
           <p:cNvSpPr txBox="1"/>
           <p:nvPr/>
         </p:nvSpPr>
@@ -10925,7 +10652,7 @@
       </p:sp>
       <p:sp>
         <p:nvSpPr>
-          <p:cNvPr id="26" name="Text 23"/>
+          <p:cNvPr id="25" name="Text 22"/>
           <p:cNvSpPr txBox="1"/>
           <p:nvPr/>
         </p:nvSpPr>
@@ -10964,7 +10691,7 @@
       </p:sp>
       <p:sp>
         <p:nvSpPr>
-          <p:cNvPr id="27" name="Text 24"/>
+          <p:cNvPr id="26" name="Text 23"/>
           <p:cNvSpPr txBox="1"/>
           <p:nvPr/>
         </p:nvSpPr>
@@ -11003,7 +10730,7 @@
       </p:sp>
       <p:sp>
         <p:nvSpPr>
-          <p:cNvPr id="28" name="Text 25"/>
+          <p:cNvPr id="27" name="Text 24"/>
           <p:cNvSpPr txBox="1"/>
           <p:nvPr/>
         </p:nvSpPr>
@@ -11042,7 +10769,7 @@
       </p:sp>
       <p:sp>
         <p:nvSpPr>
-          <p:cNvPr id="29" name="Text 26"/>
+          <p:cNvPr id="28" name="Text 25"/>
           <p:cNvSpPr txBox="1"/>
           <p:nvPr/>
         </p:nvSpPr>
@@ -11081,7 +10808,7 @@
       </p:sp>
       <p:sp>
         <p:nvSpPr>
-          <p:cNvPr id="30" name="Text 27"/>
+          <p:cNvPr id="29" name="Text 26"/>
           <p:cNvSpPr txBox="1"/>
           <p:nvPr/>
         </p:nvSpPr>
@@ -11120,7 +10847,7 @@
       </p:sp>
       <p:sp>
         <p:nvSpPr>
-          <p:cNvPr id="31" name="Text 28"/>
+          <p:cNvPr id="30" name="Text 27"/>
           <p:cNvSpPr txBox="1"/>
           <p:nvPr/>
         </p:nvSpPr>
@@ -11159,7 +10886,7 @@
       </p:sp>
       <p:sp>
         <p:nvSpPr>
-          <p:cNvPr id="32" name="Shape 29"/>
+          <p:cNvPr id="31" name="Shape 28"/>
           <p:cNvSpPr/>
           <p:nvPr/>
         </p:nvSpPr>
@@ -11179,7 +10906,7 @@
       </p:sp>
       <p:sp>
         <p:nvSpPr>
-          <p:cNvPr id="33" name="Text 30"/>
+          <p:cNvPr id="32" name="Text 29"/>
           <p:cNvSpPr txBox="1"/>
           <p:nvPr/>
         </p:nvSpPr>
@@ -11238,7 +10965,7 @@
       </p:sp>
       <p:sp>
         <p:nvSpPr>
-          <p:cNvPr id="34" name="Text 31"/>
+          <p:cNvPr id="33" name="Text 30"/>
           <p:cNvSpPr txBox="1"/>
           <p:nvPr/>
         </p:nvSpPr>
@@ -11309,36 +11036,13 @@
       </p:grpSpPr>
       <p:sp>
         <p:nvSpPr>
-          <p:cNvPr id="2" name="Shape 0"/>
-          <p:cNvSpPr/>
-          <p:nvPr/>
-        </p:nvSpPr>
-        <p:spPr>
-          <a:xfrm>
-            <a:off x="777240" y="580644"/>
-            <a:ext cx="237744" cy="0"/>
-          </a:xfrm>
-          <a:prstGeom prst="line">
-            <a:avLst/>
-          </a:prstGeom>
-          <a:noFill/>
-          <a:ln w="12700">
-            <a:solidFill>
-              <a:srgbClr val="F5DCA4"/>
-            </a:solidFill>
-            <a:prstDash val="solid"/>
-          </a:ln>
-        </p:spPr>
-      </p:sp>
-      <p:sp>
-        <p:nvSpPr>
-          <p:cNvPr id="3" name="Text 1"/>
-          <p:cNvSpPr txBox="1"/>
-          <p:nvPr/>
-        </p:nvSpPr>
-        <p:spPr>
-          <a:xfrm>
-            <a:off x="1106424" y="461772"/>
+          <p:cNvPr id="2" name="Text 0"/>
+          <p:cNvSpPr txBox="1"/>
+          <p:nvPr/>
+        </p:nvSpPr>
+        <p:spPr>
+          <a:xfrm>
+            <a:off x="777240" y="461772"/>
             <a:ext cx="5486400" cy="237744"/>
           </a:xfrm>
           <a:prstGeom prst="rect">
@@ -11371,7 +11075,7 @@
       </p:sp>
       <p:sp>
         <p:nvSpPr>
-          <p:cNvPr id="4" name="Text 2"/>
+          <p:cNvPr id="3" name="Text 1"/>
           <p:cNvSpPr txBox="1"/>
           <p:nvPr/>
         </p:nvSpPr>
@@ -11413,7 +11117,7 @@
       </p:sp>
       <p:sp>
         <p:nvSpPr>
-          <p:cNvPr id="5" name="Text 3"/>
+          <p:cNvPr id="4" name="Text 2"/>
           <p:cNvSpPr txBox="1"/>
           <p:nvPr/>
         </p:nvSpPr>
@@ -11455,78 +11159,30 @@
       </p:sp>
       <p:sp>
         <p:nvSpPr>
-          <p:cNvPr id="6" name="Shape 4"/>
-          <p:cNvSpPr/>
-          <p:nvPr/>
-        </p:nvSpPr>
-        <p:spPr>
-          <a:xfrm>
-            <a:off x="777240" y="2734945"/>
-            <a:ext cx="10637215" cy="0"/>
-          </a:xfrm>
-          <a:prstGeom prst="line">
-            <a:avLst/>
-          </a:prstGeom>
-          <a:noFill/>
-          <a:ln w="9525">
-            <a:solidFill>
-              <a:srgbClr val="33659B"/>
-            </a:solidFill>
-            <a:prstDash val="solid"/>
-          </a:ln>
-        </p:spPr>
-      </p:sp>
-      <p:sp>
-        <p:nvSpPr>
-          <p:cNvPr id="7" name="Shape 5"/>
-          <p:cNvSpPr/>
-          <p:nvPr/>
-        </p:nvSpPr>
-        <p:spPr>
-          <a:xfrm>
-            <a:off x="726948" y="2684653"/>
-            <a:ext cx="100584" cy="100584"/>
-          </a:xfrm>
-          <a:prstGeom prst="ellipse">
-            <a:avLst/>
-          </a:prstGeom>
-          <a:solidFill>
-            <a:srgbClr val="FFFFFF"/>
-          </a:solidFill>
-          <a:ln w="3175">
-            <a:solidFill>
-              <a:srgbClr val="FFFFFF"/>
-            </a:solidFill>
-            <a:prstDash val="solid"/>
-          </a:ln>
-        </p:spPr>
-      </p:sp>
-      <p:sp>
-        <p:nvSpPr>
-          <p:cNvPr id="8" name="Text 6"/>
-          <p:cNvSpPr txBox="1"/>
-          <p:nvPr/>
-        </p:nvSpPr>
-        <p:spPr>
-          <a:xfrm>
-            <a:off x="777240" y="2405761"/>
-            <a:ext cx="2487168" cy="182880"/>
-          </a:xfrm>
-          <a:prstGeom prst="rect">
-            <a:avLst/>
-          </a:prstGeom>
-          <a:noFill/>
-          <a:ln/>
-        </p:spPr>
-        <p:txBody>
-          <a:bodyPr wrap="square" lIns="0" tIns="0" rIns="0" bIns="0" rtlCol="0" anchor="ctr"/>
-          <a:lstStyle/>
-          <a:p>
-            <a:pPr indent="0" marL="0">
-              <a:buNone/>
-            </a:pPr>
-            <a:r>
-              <a:rPr lang="en-US" sz="850" spc="75" kern="0" dirty="0">
+          <p:cNvPr id="5" name="Text 3"/>
+          <p:cNvSpPr txBox="1"/>
+          <p:nvPr/>
+        </p:nvSpPr>
+        <p:spPr>
+          <a:xfrm>
+            <a:off x="777240" y="2661793"/>
+            <a:ext cx="2487168" cy="457200"/>
+          </a:xfrm>
+          <a:prstGeom prst="rect">
+            <a:avLst/>
+          </a:prstGeom>
+          <a:noFill/>
+          <a:ln/>
+        </p:spPr>
+        <p:txBody>
+          <a:bodyPr wrap="square" lIns="0" tIns="0" rIns="0" bIns="0" rtlCol="0" anchor="ctr"/>
+          <a:lstStyle/>
+          <a:p>
+            <a:pPr indent="0" marL="0">
+              <a:buNone/>
+            </a:pPr>
+            <a:r>
+              <a:rPr lang="en-US" sz="2200" spc="-40" kern="0" dirty="0">
                 <a:solidFill>
                   <a:srgbClr val="F5DCA4"/>
                 </a:solidFill>
@@ -11534,21 +11190,60 @@
                 <a:ea typeface="IBM Plex Mono" pitchFamily="34" charset="-122"/>
                 <a:cs typeface="IBM Plex Mono" pitchFamily="34" charset="-120"/>
               </a:rPr>
-              <a:t>01  MEASURE</a:t>
-            </a:r>
-            <a:endParaRPr lang="en-US" sz="850" dirty="0"/>
-          </a:p>
-        </p:txBody>
-      </p:sp>
-      <p:sp>
-        <p:nvSpPr>
-          <p:cNvPr id="9" name="Text 7"/>
-          <p:cNvSpPr txBox="1"/>
-          <p:nvPr/>
-        </p:nvSpPr>
-        <p:spPr>
-          <a:xfrm>
-            <a:off x="777240" y="2954401"/>
+              <a:t>01</a:t>
+            </a:r>
+            <a:endParaRPr lang="en-US" sz="2200" dirty="0"/>
+          </a:p>
+        </p:txBody>
+      </p:sp>
+      <p:sp>
+        <p:nvSpPr>
+          <p:cNvPr id="6" name="Text 4"/>
+          <p:cNvSpPr txBox="1"/>
+          <p:nvPr/>
+        </p:nvSpPr>
+        <p:spPr>
+          <a:xfrm>
+            <a:off x="777240" y="3155569"/>
+            <a:ext cx="2487168" cy="274320"/>
+          </a:xfrm>
+          <a:prstGeom prst="rect">
+            <a:avLst/>
+          </a:prstGeom>
+          <a:noFill/>
+          <a:ln/>
+        </p:spPr>
+        <p:txBody>
+          <a:bodyPr wrap="square" lIns="0" tIns="0" rIns="0" bIns="0" rtlCol="0" anchor="ctr"/>
+          <a:lstStyle/>
+          <a:p>
+            <a:pPr indent="0" marL="0">
+              <a:buNone/>
+            </a:pPr>
+            <a:r>
+              <a:rPr lang="en-US" sz="1400" b="1" spc="-30" kern="0" dirty="0">
+                <a:solidFill>
+                  <a:srgbClr val="FFFFFF"/>
+                </a:solidFill>
+                <a:latin typeface="Schibsted Grotesk" pitchFamily="34" charset="0"/>
+                <a:ea typeface="Schibsted Grotesk" pitchFamily="34" charset="-122"/>
+                <a:cs typeface="Schibsted Grotesk" pitchFamily="34" charset="-120"/>
+              </a:rPr>
+              <a:t>MEASURE</a:t>
+            </a:r>
+            <a:endParaRPr lang="en-US" sz="1400" dirty="0"/>
+          </a:p>
+        </p:txBody>
+      </p:sp>
+      <p:sp>
+        <p:nvSpPr>
+          <p:cNvPr id="7" name="Text 5"/>
+          <p:cNvSpPr txBox="1"/>
+          <p:nvPr/>
+        </p:nvSpPr>
+        <p:spPr>
+          <a:xfrm>
+            <a:off x="777240" y="3521329"/>
             <a:ext cx="2395728" cy="1097280"/>
           </a:xfrm>
           <a:prstGeom prst="rect">
@@ -11584,101 +11279,30 @@
       </p:sp>
       <p:sp>
         <p:nvSpPr>
-          <p:cNvPr id="10" name="Shape 8"/>
-          <p:cNvSpPr/>
-          <p:nvPr/>
-        </p:nvSpPr>
-        <p:spPr>
-          <a:xfrm>
-            <a:off x="3305556" y="2666365"/>
-            <a:ext cx="86868" cy="68580"/>
-          </a:xfrm>
-          <a:prstGeom prst="line">
-            <a:avLst/>
-          </a:prstGeom>
-          <a:noFill/>
-          <a:ln w="11430">
-            <a:solidFill>
-              <a:srgbClr val="8CA9C7"/>
-            </a:solidFill>
-            <a:prstDash val="solid"/>
-          </a:ln>
-        </p:spPr>
-      </p:sp>
-      <p:sp>
-        <p:nvSpPr>
-          <p:cNvPr id="11" name="Shape 9"/>
-          <p:cNvSpPr/>
-          <p:nvPr/>
-        </p:nvSpPr>
-        <p:spPr>
-          <a:xfrm flipV="1">
-            <a:off x="3305556" y="2734945"/>
-            <a:ext cx="86868" cy="68580"/>
-          </a:xfrm>
-          <a:prstGeom prst="line">
-            <a:avLst/>
-          </a:prstGeom>
-          <a:noFill/>
-          <a:ln w="11430">
-            <a:solidFill>
-              <a:srgbClr val="8CA9C7"/>
-            </a:solidFill>
-            <a:prstDash val="solid"/>
-          </a:ln>
-        </p:spPr>
-      </p:sp>
-      <p:sp>
-        <p:nvSpPr>
-          <p:cNvPr id="12" name="Shape 10"/>
-          <p:cNvSpPr/>
-          <p:nvPr/>
-        </p:nvSpPr>
-        <p:spPr>
-          <a:xfrm>
-            <a:off x="3433572" y="2684653"/>
-            <a:ext cx="100584" cy="100584"/>
-          </a:xfrm>
-          <a:prstGeom prst="ellipse">
-            <a:avLst/>
-          </a:prstGeom>
-          <a:solidFill>
-            <a:srgbClr val="FFFFFF"/>
-          </a:solidFill>
-          <a:ln w="3175">
-            <a:solidFill>
-              <a:srgbClr val="FFFFFF"/>
-            </a:solidFill>
-            <a:prstDash val="solid"/>
-          </a:ln>
-        </p:spPr>
-      </p:sp>
-      <p:sp>
-        <p:nvSpPr>
-          <p:cNvPr id="13" name="Text 11"/>
-          <p:cNvSpPr txBox="1"/>
-          <p:nvPr/>
-        </p:nvSpPr>
-        <p:spPr>
-          <a:xfrm>
-            <a:off x="3483864" y="2405761"/>
-            <a:ext cx="2487168" cy="182880"/>
-          </a:xfrm>
-          <a:prstGeom prst="rect">
-            <a:avLst/>
-          </a:prstGeom>
-          <a:noFill/>
-          <a:ln/>
-        </p:spPr>
-        <p:txBody>
-          <a:bodyPr wrap="square" lIns="0" tIns="0" rIns="0" bIns="0" rtlCol="0" anchor="ctr"/>
-          <a:lstStyle/>
-          <a:p>
-            <a:pPr indent="0" marL="0">
-              <a:buNone/>
-            </a:pPr>
-            <a:r>
-              <a:rPr lang="en-US" sz="850" spc="75" kern="0" dirty="0">
+          <p:cNvPr id="8" name="Text 6"/>
+          <p:cNvSpPr txBox="1"/>
+          <p:nvPr/>
+        </p:nvSpPr>
+        <p:spPr>
+          <a:xfrm>
+            <a:off x="3483864" y="2661793"/>
+            <a:ext cx="2487168" cy="457200"/>
+          </a:xfrm>
+          <a:prstGeom prst="rect">
+            <a:avLst/>
+          </a:prstGeom>
+          <a:noFill/>
+          <a:ln/>
+        </p:spPr>
+        <p:txBody>
+          <a:bodyPr wrap="square" lIns="0" tIns="0" rIns="0" bIns="0" rtlCol="0" anchor="ctr"/>
+          <a:lstStyle/>
+          <a:p>
+            <a:pPr indent="0" marL="0">
+              <a:buNone/>
+            </a:pPr>
+            <a:r>
+              <a:rPr lang="en-US" sz="2200" spc="-40" kern="0" dirty="0">
                 <a:solidFill>
                   <a:srgbClr val="F5DCA4"/>
                 </a:solidFill>
@@ -11686,21 +11310,60 @@
                 <a:ea typeface="IBM Plex Mono" pitchFamily="34" charset="-122"/>
                 <a:cs typeface="IBM Plex Mono" pitchFamily="34" charset="-120"/>
               </a:rPr>
-              <a:t>02  COMPARE</a:t>
-            </a:r>
-            <a:endParaRPr lang="en-US" sz="850" dirty="0"/>
-          </a:p>
-        </p:txBody>
-      </p:sp>
-      <p:sp>
-        <p:nvSpPr>
-          <p:cNvPr id="14" name="Text 12"/>
-          <p:cNvSpPr txBox="1"/>
-          <p:nvPr/>
-        </p:nvSpPr>
-        <p:spPr>
-          <a:xfrm>
-            <a:off x="3483864" y="2954401"/>
+              <a:t>02</a:t>
+            </a:r>
+            <a:endParaRPr lang="en-US" sz="2200" dirty="0"/>
+          </a:p>
+        </p:txBody>
+      </p:sp>
+      <p:sp>
+        <p:nvSpPr>
+          <p:cNvPr id="9" name="Text 7"/>
+          <p:cNvSpPr txBox="1"/>
+          <p:nvPr/>
+        </p:nvSpPr>
+        <p:spPr>
+          <a:xfrm>
+            <a:off x="3483864" y="3155569"/>
+            <a:ext cx="2487168" cy="274320"/>
+          </a:xfrm>
+          <a:prstGeom prst="rect">
+            <a:avLst/>
+          </a:prstGeom>
+          <a:noFill/>
+          <a:ln/>
+        </p:spPr>
+        <p:txBody>
+          <a:bodyPr wrap="square" lIns="0" tIns="0" rIns="0" bIns="0" rtlCol="0" anchor="ctr"/>
+          <a:lstStyle/>
+          <a:p>
+            <a:pPr indent="0" marL="0">
+              <a:buNone/>
+            </a:pPr>
+            <a:r>
+              <a:rPr lang="en-US" sz="1400" b="1" spc="-30" kern="0" dirty="0">
+                <a:solidFill>
+                  <a:srgbClr val="FFFFFF"/>
+                </a:solidFill>
+                <a:latin typeface="Schibsted Grotesk" pitchFamily="34" charset="0"/>
+                <a:ea typeface="Schibsted Grotesk" pitchFamily="34" charset="-122"/>
+                <a:cs typeface="Schibsted Grotesk" pitchFamily="34" charset="-120"/>
+              </a:rPr>
+              <a:t>COMPARE</a:t>
+            </a:r>
+            <a:endParaRPr lang="en-US" sz="1400" dirty="0"/>
+          </a:p>
+        </p:txBody>
+      </p:sp>
+      <p:sp>
+        <p:nvSpPr>
+          <p:cNvPr id="10" name="Text 8"/>
+          <p:cNvSpPr txBox="1"/>
+          <p:nvPr/>
+        </p:nvSpPr>
+        <p:spPr>
+          <a:xfrm>
+            <a:off x="3483864" y="3521329"/>
             <a:ext cx="2395728" cy="1097280"/>
           </a:xfrm>
           <a:prstGeom prst="rect">
@@ -11736,101 +11399,30 @@
       </p:sp>
       <p:sp>
         <p:nvSpPr>
-          <p:cNvPr id="15" name="Shape 13"/>
-          <p:cNvSpPr/>
-          <p:nvPr/>
-        </p:nvSpPr>
-        <p:spPr>
-          <a:xfrm>
-            <a:off x="6012180" y="2666365"/>
-            <a:ext cx="86868" cy="68580"/>
-          </a:xfrm>
-          <a:prstGeom prst="line">
-            <a:avLst/>
-          </a:prstGeom>
-          <a:noFill/>
-          <a:ln w="11430">
-            <a:solidFill>
-              <a:srgbClr val="8CA9C7"/>
-            </a:solidFill>
-            <a:prstDash val="solid"/>
-          </a:ln>
-        </p:spPr>
-      </p:sp>
-      <p:sp>
-        <p:nvSpPr>
-          <p:cNvPr id="16" name="Shape 14"/>
-          <p:cNvSpPr/>
-          <p:nvPr/>
-        </p:nvSpPr>
-        <p:spPr>
-          <a:xfrm flipV="1">
-            <a:off x="6012180" y="2734945"/>
-            <a:ext cx="86868" cy="68580"/>
-          </a:xfrm>
-          <a:prstGeom prst="line">
-            <a:avLst/>
-          </a:prstGeom>
-          <a:noFill/>
-          <a:ln w="11430">
-            <a:solidFill>
-              <a:srgbClr val="8CA9C7"/>
-            </a:solidFill>
-            <a:prstDash val="solid"/>
-          </a:ln>
-        </p:spPr>
-      </p:sp>
-      <p:sp>
-        <p:nvSpPr>
-          <p:cNvPr id="17" name="Shape 15"/>
-          <p:cNvSpPr/>
-          <p:nvPr/>
-        </p:nvSpPr>
-        <p:spPr>
-          <a:xfrm>
-            <a:off x="6140196" y="2684653"/>
-            <a:ext cx="100584" cy="100584"/>
-          </a:xfrm>
-          <a:prstGeom prst="ellipse">
-            <a:avLst/>
-          </a:prstGeom>
-          <a:solidFill>
-            <a:srgbClr val="FFFFFF"/>
-          </a:solidFill>
-          <a:ln w="3175">
-            <a:solidFill>
-              <a:srgbClr val="FFFFFF"/>
-            </a:solidFill>
-            <a:prstDash val="solid"/>
-          </a:ln>
-        </p:spPr>
-      </p:sp>
-      <p:sp>
-        <p:nvSpPr>
-          <p:cNvPr id="18" name="Text 16"/>
-          <p:cNvSpPr txBox="1"/>
-          <p:nvPr/>
-        </p:nvSpPr>
-        <p:spPr>
-          <a:xfrm>
-            <a:off x="6190488" y="2405761"/>
-            <a:ext cx="2487168" cy="182880"/>
-          </a:xfrm>
-          <a:prstGeom prst="rect">
-            <a:avLst/>
-          </a:prstGeom>
-          <a:noFill/>
-          <a:ln/>
-        </p:spPr>
-        <p:txBody>
-          <a:bodyPr wrap="square" lIns="0" tIns="0" rIns="0" bIns="0" rtlCol="0" anchor="ctr"/>
-          <a:lstStyle/>
-          <a:p>
-            <a:pPr indent="0" marL="0">
-              <a:buNone/>
-            </a:pPr>
-            <a:r>
-              <a:rPr lang="en-US" sz="850" spc="75" kern="0" dirty="0">
+          <p:cNvPr id="11" name="Text 9"/>
+          <p:cNvSpPr txBox="1"/>
+          <p:nvPr/>
+        </p:nvSpPr>
+        <p:spPr>
+          <a:xfrm>
+            <a:off x="6190488" y="2661793"/>
+            <a:ext cx="2487168" cy="457200"/>
+          </a:xfrm>
+          <a:prstGeom prst="rect">
+            <a:avLst/>
+          </a:prstGeom>
+          <a:noFill/>
+          <a:ln/>
+        </p:spPr>
+        <p:txBody>
+          <a:bodyPr wrap="square" lIns="0" tIns="0" rIns="0" bIns="0" rtlCol="0" anchor="ctr"/>
+          <a:lstStyle/>
+          <a:p>
+            <a:pPr indent="0" marL="0">
+              <a:buNone/>
+            </a:pPr>
+            <a:r>
+              <a:rPr lang="en-US" sz="2200" spc="-40" kern="0" dirty="0">
                 <a:solidFill>
                   <a:srgbClr val="F5DCA4"/>
                 </a:solidFill>
@@ -11838,21 +11430,60 @@
                 <a:ea typeface="IBM Plex Mono" pitchFamily="34" charset="-122"/>
                 <a:cs typeface="IBM Plex Mono" pitchFamily="34" charset="-120"/>
               </a:rPr>
-              <a:t>03  DECIDE</a:t>
-            </a:r>
-            <a:endParaRPr lang="en-US" sz="850" dirty="0"/>
-          </a:p>
-        </p:txBody>
-      </p:sp>
-      <p:sp>
-        <p:nvSpPr>
-          <p:cNvPr id="19" name="Text 17"/>
-          <p:cNvSpPr txBox="1"/>
-          <p:nvPr/>
-        </p:nvSpPr>
-        <p:spPr>
-          <a:xfrm>
-            <a:off x="6190488" y="2954401"/>
+              <a:t>03</a:t>
+            </a:r>
+            <a:endParaRPr lang="en-US" sz="2200" dirty="0"/>
+          </a:p>
+        </p:txBody>
+      </p:sp>
+      <p:sp>
+        <p:nvSpPr>
+          <p:cNvPr id="12" name="Text 10"/>
+          <p:cNvSpPr txBox="1"/>
+          <p:nvPr/>
+        </p:nvSpPr>
+        <p:spPr>
+          <a:xfrm>
+            <a:off x="6190488" y="3155569"/>
+            <a:ext cx="2487168" cy="274320"/>
+          </a:xfrm>
+          <a:prstGeom prst="rect">
+            <a:avLst/>
+          </a:prstGeom>
+          <a:noFill/>
+          <a:ln/>
+        </p:spPr>
+        <p:txBody>
+          <a:bodyPr wrap="square" lIns="0" tIns="0" rIns="0" bIns="0" rtlCol="0" anchor="ctr"/>
+          <a:lstStyle/>
+          <a:p>
+            <a:pPr indent="0" marL="0">
+              <a:buNone/>
+            </a:pPr>
+            <a:r>
+              <a:rPr lang="en-US" sz="1400" b="1" spc="-30" kern="0" dirty="0">
+                <a:solidFill>
+                  <a:srgbClr val="FFFFFF"/>
+                </a:solidFill>
+                <a:latin typeface="Schibsted Grotesk" pitchFamily="34" charset="0"/>
+                <a:ea typeface="Schibsted Grotesk" pitchFamily="34" charset="-122"/>
+                <a:cs typeface="Schibsted Grotesk" pitchFamily="34" charset="-120"/>
+              </a:rPr>
+              <a:t>DECIDE</a:t>
+            </a:r>
+            <a:endParaRPr lang="en-US" sz="1400" dirty="0"/>
+          </a:p>
+        </p:txBody>
+      </p:sp>
+      <p:sp>
+        <p:nvSpPr>
+          <p:cNvPr id="13" name="Text 11"/>
+          <p:cNvSpPr txBox="1"/>
+          <p:nvPr/>
+        </p:nvSpPr>
+        <p:spPr>
+          <a:xfrm>
+            <a:off x="6190488" y="3521329"/>
             <a:ext cx="2395728" cy="1097280"/>
           </a:xfrm>
           <a:prstGeom prst="rect">
@@ -11888,101 +11519,30 @@
       </p:sp>
       <p:sp>
         <p:nvSpPr>
-          <p:cNvPr id="20" name="Shape 18"/>
-          <p:cNvSpPr/>
-          <p:nvPr/>
-        </p:nvSpPr>
-        <p:spPr>
-          <a:xfrm>
-            <a:off x="8718804" y="2666365"/>
-            <a:ext cx="86868" cy="68580"/>
-          </a:xfrm>
-          <a:prstGeom prst="line">
-            <a:avLst/>
-          </a:prstGeom>
-          <a:noFill/>
-          <a:ln w="11430">
-            <a:solidFill>
-              <a:srgbClr val="8CA9C7"/>
-            </a:solidFill>
-            <a:prstDash val="solid"/>
-          </a:ln>
-        </p:spPr>
-      </p:sp>
-      <p:sp>
-        <p:nvSpPr>
-          <p:cNvPr id="21" name="Shape 19"/>
-          <p:cNvSpPr/>
-          <p:nvPr/>
-        </p:nvSpPr>
-        <p:spPr>
-          <a:xfrm flipV="1">
-            <a:off x="8718804" y="2734945"/>
-            <a:ext cx="86868" cy="68580"/>
-          </a:xfrm>
-          <a:prstGeom prst="line">
-            <a:avLst/>
-          </a:prstGeom>
-          <a:noFill/>
-          <a:ln w="11430">
-            <a:solidFill>
-              <a:srgbClr val="8CA9C7"/>
-            </a:solidFill>
-            <a:prstDash val="solid"/>
-          </a:ln>
-        </p:spPr>
-      </p:sp>
-      <p:sp>
-        <p:nvSpPr>
-          <p:cNvPr id="22" name="Shape 20"/>
-          <p:cNvSpPr/>
-          <p:nvPr/>
-        </p:nvSpPr>
-        <p:spPr>
-          <a:xfrm>
-            <a:off x="8846820" y="2684653"/>
-            <a:ext cx="100584" cy="100584"/>
-          </a:xfrm>
-          <a:prstGeom prst="ellipse">
-            <a:avLst/>
-          </a:prstGeom>
-          <a:solidFill>
-            <a:srgbClr val="E8B33A"/>
-          </a:solidFill>
-          <a:ln w="3175">
-            <a:solidFill>
-              <a:srgbClr val="E8B33A"/>
-            </a:solidFill>
-            <a:prstDash val="solid"/>
-          </a:ln>
-        </p:spPr>
-      </p:sp>
-      <p:sp>
-        <p:nvSpPr>
-          <p:cNvPr id="23" name="Text 21"/>
-          <p:cNvSpPr txBox="1"/>
-          <p:nvPr/>
-        </p:nvSpPr>
-        <p:spPr>
-          <a:xfrm>
-            <a:off x="8897112" y="2405761"/>
-            <a:ext cx="2487168" cy="182880"/>
-          </a:xfrm>
-          <a:prstGeom prst="rect">
-            <a:avLst/>
-          </a:prstGeom>
-          <a:noFill/>
-          <a:ln/>
-        </p:spPr>
-        <p:txBody>
-          <a:bodyPr wrap="square" lIns="0" tIns="0" rIns="0" bIns="0" rtlCol="0" anchor="ctr"/>
-          <a:lstStyle/>
-          <a:p>
-            <a:pPr indent="0" marL="0">
-              <a:buNone/>
-            </a:pPr>
-            <a:r>
-              <a:rPr lang="en-US" sz="850" spc="75" kern="0" dirty="0">
+          <p:cNvPr id="14" name="Text 12"/>
+          <p:cNvSpPr txBox="1"/>
+          <p:nvPr/>
+        </p:nvSpPr>
+        <p:spPr>
+          <a:xfrm>
+            <a:off x="8897112" y="2661793"/>
+            <a:ext cx="2487168" cy="457200"/>
+          </a:xfrm>
+          <a:prstGeom prst="rect">
+            <a:avLst/>
+          </a:prstGeom>
+          <a:noFill/>
+          <a:ln/>
+        </p:spPr>
+        <p:txBody>
+          <a:bodyPr wrap="square" lIns="0" tIns="0" rIns="0" bIns="0" rtlCol="0" anchor="ctr"/>
+          <a:lstStyle/>
+          <a:p>
+            <a:pPr indent="0" marL="0">
+              <a:buNone/>
+            </a:pPr>
+            <a:r>
+              <a:rPr lang="en-US" sz="2200" spc="-40" kern="0" dirty="0">
                 <a:solidFill>
                   <a:srgbClr val="E8B33A"/>
                 </a:solidFill>
@@ -11990,21 +11550,60 @@
                 <a:ea typeface="IBM Plex Mono" pitchFamily="34" charset="-122"/>
                 <a:cs typeface="IBM Plex Mono" pitchFamily="34" charset="-120"/>
               </a:rPr>
-              <a:t>04  OWN</a:t>
-            </a:r>
-            <a:endParaRPr lang="en-US" sz="850" dirty="0"/>
-          </a:p>
-        </p:txBody>
-      </p:sp>
-      <p:sp>
-        <p:nvSpPr>
-          <p:cNvPr id="24" name="Text 22"/>
-          <p:cNvSpPr txBox="1"/>
-          <p:nvPr/>
-        </p:nvSpPr>
-        <p:spPr>
-          <a:xfrm>
-            <a:off x="8897112" y="2954401"/>
+              <a:t>04</a:t>
+            </a:r>
+            <a:endParaRPr lang="en-US" sz="2200" dirty="0"/>
+          </a:p>
+        </p:txBody>
+      </p:sp>
+      <p:sp>
+        <p:nvSpPr>
+          <p:cNvPr id="15" name="Text 13"/>
+          <p:cNvSpPr txBox="1"/>
+          <p:nvPr/>
+        </p:nvSpPr>
+        <p:spPr>
+          <a:xfrm>
+            <a:off x="8897112" y="3155569"/>
+            <a:ext cx="2487168" cy="274320"/>
+          </a:xfrm>
+          <a:prstGeom prst="rect">
+            <a:avLst/>
+          </a:prstGeom>
+          <a:noFill/>
+          <a:ln/>
+        </p:spPr>
+        <p:txBody>
+          <a:bodyPr wrap="square" lIns="0" tIns="0" rIns="0" bIns="0" rtlCol="0" anchor="ctr"/>
+          <a:lstStyle/>
+          <a:p>
+            <a:pPr indent="0" marL="0">
+              <a:buNone/>
+            </a:pPr>
+            <a:r>
+              <a:rPr lang="en-US" sz="1400" b="1" spc="-30" kern="0" dirty="0">
+                <a:solidFill>
+                  <a:srgbClr val="FFFFFF"/>
+                </a:solidFill>
+                <a:latin typeface="Schibsted Grotesk" pitchFamily="34" charset="0"/>
+                <a:ea typeface="Schibsted Grotesk" pitchFamily="34" charset="-122"/>
+                <a:cs typeface="Schibsted Grotesk" pitchFamily="34" charset="-120"/>
+              </a:rPr>
+              <a:t>OWN</a:t>
+            </a:r>
+            <a:endParaRPr lang="en-US" sz="1400" dirty="0"/>
+          </a:p>
+        </p:txBody>
+      </p:sp>
+      <p:sp>
+        <p:nvSpPr>
+          <p:cNvPr id="16" name="Text 14"/>
+          <p:cNvSpPr txBox="1"/>
+          <p:nvPr/>
+        </p:nvSpPr>
+        <p:spPr>
+          <a:xfrm>
+            <a:off x="8897112" y="3521329"/>
             <a:ext cx="2395728" cy="1097280"/>
           </a:xfrm>
           <a:prstGeom prst="rect">
@@ -12040,13 +11639,13 @@
       </p:sp>
       <p:sp>
         <p:nvSpPr>
-          <p:cNvPr id="25" name="Text 23"/>
-          <p:cNvSpPr txBox="1"/>
-          <p:nvPr/>
-        </p:nvSpPr>
-        <p:spPr>
-          <a:xfrm>
-            <a:off x="777240" y="4673473"/>
+          <p:cNvPr id="17" name="Text 15"/>
+          <p:cNvSpPr txBox="1"/>
+          <p:nvPr/>
+        </p:nvSpPr>
+        <p:spPr>
+          <a:xfrm>
+            <a:off x="777240" y="4911217"/>
             <a:ext cx="5062576" cy="237744"/>
           </a:xfrm>
           <a:prstGeom prst="rect">
@@ -12079,13 +11678,13 @@
       </p:sp>
       <p:sp>
         <p:nvSpPr>
-          <p:cNvPr id="26" name="Text 24"/>
-          <p:cNvSpPr txBox="1"/>
-          <p:nvPr/>
-        </p:nvSpPr>
-        <p:spPr>
-          <a:xfrm>
-            <a:off x="777240" y="4956937"/>
+          <p:cNvPr id="18" name="Text 16"/>
+          <p:cNvSpPr txBox="1"/>
+          <p:nvPr/>
+        </p:nvSpPr>
+        <p:spPr>
+          <a:xfrm>
+            <a:off x="777240" y="5194681"/>
             <a:ext cx="5062576" cy="548640"/>
           </a:xfrm>
           <a:prstGeom prst="rect">
@@ -12121,13 +11720,13 @@
       </p:sp>
       <p:sp>
         <p:nvSpPr>
-          <p:cNvPr id="27" name="Text 25"/>
-          <p:cNvSpPr txBox="1"/>
-          <p:nvPr/>
-        </p:nvSpPr>
-        <p:spPr>
-          <a:xfrm>
-            <a:off x="6223864" y="4673473"/>
+          <p:cNvPr id="19" name="Text 17"/>
+          <p:cNvSpPr txBox="1"/>
+          <p:nvPr/>
+        </p:nvSpPr>
+        <p:spPr>
+          <a:xfrm>
+            <a:off x="6223864" y="4911217"/>
             <a:ext cx="5062576" cy="237744"/>
           </a:xfrm>
           <a:prstGeom prst="rect">
@@ -12160,13 +11759,13 @@
       </p:sp>
       <p:sp>
         <p:nvSpPr>
-          <p:cNvPr id="28" name="Text 26"/>
-          <p:cNvSpPr txBox="1"/>
-          <p:nvPr/>
-        </p:nvSpPr>
-        <p:spPr>
-          <a:xfrm>
-            <a:off x="6223864" y="4956937"/>
+          <p:cNvPr id="20" name="Text 18"/>
+          <p:cNvSpPr txBox="1"/>
+          <p:nvPr/>
+        </p:nvSpPr>
+        <p:spPr>
+          <a:xfrm>
+            <a:off x="6223864" y="5194681"/>
             <a:ext cx="5062576" cy="548640"/>
           </a:xfrm>
           <a:prstGeom prst="rect">
@@ -12202,7 +11801,7 @@
       </p:sp>
       <p:sp>
         <p:nvSpPr>
-          <p:cNvPr id="29" name="Text 27"/>
+          <p:cNvPr id="21" name="Text 19"/>
           <p:cNvSpPr txBox="1"/>
           <p:nvPr/>
         </p:nvSpPr>
@@ -12241,7 +11840,7 @@
       </p:sp>
       <p:sp>
         <p:nvSpPr>
-          <p:cNvPr id="30" name="Text 28"/>
+          <p:cNvPr id="22" name="Text 20"/>
           <p:cNvSpPr txBox="1"/>
           <p:nvPr/>
         </p:nvSpPr>
@@ -12312,36 +11911,13 @@
       </p:grpSpPr>
       <p:sp>
         <p:nvSpPr>
-          <p:cNvPr id="2" name="Shape 0"/>
-          <p:cNvSpPr/>
-          <p:nvPr/>
-        </p:nvSpPr>
-        <p:spPr>
-          <a:xfrm>
-            <a:off x="777240" y="580644"/>
-            <a:ext cx="237744" cy="0"/>
-          </a:xfrm>
-          <a:prstGeom prst="line">
-            <a:avLst/>
-          </a:prstGeom>
-          <a:noFill/>
-          <a:ln w="12700">
-            <a:solidFill>
-              <a:srgbClr val="11676A"/>
-            </a:solidFill>
-            <a:prstDash val="solid"/>
-          </a:ln>
-        </p:spPr>
-      </p:sp>
-      <p:sp>
-        <p:nvSpPr>
-          <p:cNvPr id="3" name="Text 1"/>
-          <p:cNvSpPr txBox="1"/>
-          <p:nvPr/>
-        </p:nvSpPr>
-        <p:spPr>
-          <a:xfrm>
-            <a:off x="1106424" y="461772"/>
+          <p:cNvPr id="2" name="Text 0"/>
+          <p:cNvSpPr txBox="1"/>
+          <p:nvPr/>
+        </p:nvSpPr>
+        <p:spPr>
+          <a:xfrm>
+            <a:off x="777240" y="461772"/>
             <a:ext cx="5486400" cy="237744"/>
           </a:xfrm>
           <a:prstGeom prst="rect">
@@ -12374,7 +11950,7 @@
       </p:sp>
       <p:sp>
         <p:nvSpPr>
-          <p:cNvPr id="4" name="Text 2"/>
+          <p:cNvPr id="3" name="Text 1"/>
           <p:cNvSpPr txBox="1"/>
           <p:nvPr/>
         </p:nvSpPr>
@@ -12416,7 +11992,7 @@
       </p:sp>
       <p:sp>
         <p:nvSpPr>
-          <p:cNvPr id="5" name="Text 3"/>
+          <p:cNvPr id="4" name="Text 2"/>
           <p:cNvSpPr txBox="1"/>
           <p:nvPr/>
         </p:nvSpPr>
@@ -12458,7 +12034,7 @@
       </p:sp>
       <p:pic>
         <p:nvPicPr>
-          <p:cNvPr id="6" name="Image 0" descr="./assets/fig-process.jpg">    </p:cNvPr>
+          <p:cNvPr id="5" name="Image 0" descr="./assets/fig-process.jpg">    </p:cNvPr>
           <p:cNvPicPr>
             <a:picLocks noChangeAspect="1"/>
           </p:cNvPicPr>
@@ -12482,7 +12058,7 @@
       </p:pic>
       <p:sp>
         <p:nvSpPr>
-          <p:cNvPr id="7" name="Text 4"/>
+          <p:cNvPr id="6" name="Text 3"/>
           <p:cNvSpPr txBox="1"/>
           <p:nvPr/>
         </p:nvSpPr>
@@ -12521,7 +12097,7 @@
       </p:sp>
       <p:sp>
         <p:nvSpPr>
-          <p:cNvPr id="8" name="Text 5"/>
+          <p:cNvPr id="7" name="Text 4"/>
           <p:cNvSpPr txBox="1"/>
           <p:nvPr/>
         </p:nvSpPr>
@@ -12560,7 +12136,7 @@
       </p:sp>
       <p:sp>
         <p:nvSpPr>
-          <p:cNvPr id="9" name="Text 6"/>
+          <p:cNvPr id="8" name="Text 5"/>
           <p:cNvSpPr txBox="1"/>
           <p:nvPr/>
         </p:nvSpPr>
@@ -12599,7 +12175,7 @@
       </p:sp>
       <p:sp>
         <p:nvSpPr>
-          <p:cNvPr id="10" name="Text 7"/>
+          <p:cNvPr id="9" name="Text 6"/>
           <p:cNvSpPr txBox="1"/>
           <p:nvPr/>
         </p:nvSpPr>
@@ -12638,7 +12214,7 @@
       </p:sp>
       <p:sp>
         <p:nvSpPr>
-          <p:cNvPr id="11" name="Text 8"/>
+          <p:cNvPr id="10" name="Text 7"/>
           <p:cNvSpPr txBox="1"/>
           <p:nvPr/>
         </p:nvSpPr>
@@ -12677,7 +12253,7 @@
       </p:sp>
       <p:sp>
         <p:nvSpPr>
-          <p:cNvPr id="12" name="Text 9"/>
+          <p:cNvPr id="11" name="Text 8"/>
           <p:cNvSpPr txBox="1"/>
           <p:nvPr/>
         </p:nvSpPr>
@@ -12716,7 +12292,7 @@
       </p:sp>
       <p:sp>
         <p:nvSpPr>
-          <p:cNvPr id="13" name="Text 10"/>
+          <p:cNvPr id="12" name="Text 9"/>
           <p:cNvSpPr txBox="1"/>
           <p:nvPr/>
         </p:nvSpPr>
@@ -12755,7 +12331,7 @@
       </p:sp>
       <p:sp>
         <p:nvSpPr>
-          <p:cNvPr id="14" name="Text 11"/>
+          <p:cNvPr id="13" name="Text 10"/>
           <p:cNvSpPr txBox="1"/>
           <p:nvPr/>
         </p:nvSpPr>
@@ -12794,7 +12370,7 @@
       </p:sp>
       <p:sp>
         <p:nvSpPr>
-          <p:cNvPr id="15" name="Text 12"/>
+          <p:cNvPr id="14" name="Text 11"/>
           <p:cNvSpPr txBox="1"/>
           <p:nvPr/>
         </p:nvSpPr>
@@ -12833,7 +12409,7 @@
       </p:sp>
       <p:sp>
         <p:nvSpPr>
-          <p:cNvPr id="16" name="Text 13"/>
+          <p:cNvPr id="15" name="Text 12"/>
           <p:cNvSpPr txBox="1"/>
           <p:nvPr/>
         </p:nvSpPr>
@@ -12872,7 +12448,7 @@
       </p:sp>
       <p:sp>
         <p:nvSpPr>
-          <p:cNvPr id="17" name="Text 14"/>
+          <p:cNvPr id="16" name="Text 13"/>
           <p:cNvSpPr txBox="1"/>
           <p:nvPr/>
         </p:nvSpPr>
@@ -12911,7 +12487,7 @@
       </p:sp>
       <p:sp>
         <p:nvSpPr>
-          <p:cNvPr id="18" name="Text 15"/>
+          <p:cNvPr id="17" name="Text 14"/>
           <p:cNvSpPr txBox="1"/>
           <p:nvPr/>
         </p:nvSpPr>
@@ -12950,7 +12526,7 @@
       </p:sp>
       <p:sp>
         <p:nvSpPr>
-          <p:cNvPr id="19" name="Text 16"/>
+          <p:cNvPr id="18" name="Text 15"/>
           <p:cNvSpPr txBox="1"/>
           <p:nvPr/>
         </p:nvSpPr>
@@ -12989,7 +12565,7 @@
       </p:sp>
       <p:sp>
         <p:nvSpPr>
-          <p:cNvPr id="20" name="Text 17"/>
+          <p:cNvPr id="19" name="Text 16"/>
           <p:cNvSpPr txBox="1"/>
           <p:nvPr/>
         </p:nvSpPr>
@@ -13028,7 +12604,7 @@
       </p:sp>
       <p:sp>
         <p:nvSpPr>
-          <p:cNvPr id="21" name="Text 18"/>
+          <p:cNvPr id="20" name="Text 17"/>
           <p:cNvSpPr txBox="1"/>
           <p:nvPr/>
         </p:nvSpPr>
@@ -13099,36 +12675,13 @@
       </p:grpSpPr>
       <p:sp>
         <p:nvSpPr>
-          <p:cNvPr id="2" name="Shape 0"/>
-          <p:cNvSpPr/>
-          <p:nvPr/>
-        </p:nvSpPr>
-        <p:spPr>
-          <a:xfrm>
-            <a:off x="777240" y="580644"/>
-            <a:ext cx="237744" cy="0"/>
-          </a:xfrm>
-          <a:prstGeom prst="line">
-            <a:avLst/>
-          </a:prstGeom>
-          <a:noFill/>
-          <a:ln w="12700">
-            <a:solidFill>
-              <a:srgbClr val="11676A"/>
-            </a:solidFill>
-            <a:prstDash val="solid"/>
-          </a:ln>
-        </p:spPr>
-      </p:sp>
-      <p:sp>
-        <p:nvSpPr>
-          <p:cNvPr id="3" name="Text 1"/>
-          <p:cNvSpPr txBox="1"/>
-          <p:nvPr/>
-        </p:nvSpPr>
-        <p:spPr>
-          <a:xfrm>
-            <a:off x="1106424" y="461772"/>
+          <p:cNvPr id="2" name="Text 0"/>
+          <p:cNvSpPr txBox="1"/>
+          <p:nvPr/>
+        </p:nvSpPr>
+        <p:spPr>
+          <a:xfrm>
+            <a:off x="777240" y="461772"/>
             <a:ext cx="5486400" cy="237744"/>
           </a:xfrm>
           <a:prstGeom prst="rect">
@@ -13161,7 +12714,7 @@
       </p:sp>
       <p:sp>
         <p:nvSpPr>
-          <p:cNvPr id="4" name="Text 2"/>
+          <p:cNvPr id="3" name="Text 1"/>
           <p:cNvSpPr txBox="1"/>
           <p:nvPr/>
         </p:nvSpPr>
@@ -13203,7 +12756,7 @@
       </p:sp>
       <p:sp>
         <p:nvSpPr>
-          <p:cNvPr id="5" name="Text 3"/>
+          <p:cNvPr id="4" name="Text 2"/>
           <p:cNvSpPr txBox="1"/>
           <p:nvPr/>
         </p:nvSpPr>
@@ -13245,7 +12798,7 @@
       </p:sp>
       <p:pic>
         <p:nvPicPr>
-          <p:cNvPr id="6" name="Image 0" descr="./assets/fig-ai.jpg">    </p:cNvPr>
+          <p:cNvPr id="5" name="Image 0" descr="./assets/fig-ai.jpg">    </p:cNvPr>
           <p:cNvPicPr>
             <a:picLocks noChangeAspect="1"/>
           </p:cNvPicPr>
@@ -13269,7 +12822,7 @@
       </p:pic>
       <p:sp>
         <p:nvSpPr>
-          <p:cNvPr id="7" name="Text 4"/>
+          <p:cNvPr id="6" name="Text 3"/>
           <p:cNvSpPr txBox="1"/>
           <p:nvPr/>
         </p:nvSpPr>
@@ -13308,7 +12861,7 @@
       </p:sp>
       <p:sp>
         <p:nvSpPr>
-          <p:cNvPr id="8" name="Text 5"/>
+          <p:cNvPr id="7" name="Text 4"/>
           <p:cNvSpPr txBox="1"/>
           <p:nvPr/>
         </p:nvSpPr>
@@ -13347,7 +12900,7 @@
       </p:sp>
       <p:sp>
         <p:nvSpPr>
-          <p:cNvPr id="9" name="Shape 6"/>
+          <p:cNvPr id="8" name="Shape 5"/>
           <p:cNvSpPr/>
           <p:nvPr/>
         </p:nvSpPr>
@@ -13372,7 +12925,7 @@
       </p:sp>
       <p:sp>
         <p:nvSpPr>
-          <p:cNvPr id="10" name="Text 7"/>
+          <p:cNvPr id="9" name="Text 6"/>
           <p:cNvSpPr txBox="1"/>
           <p:nvPr/>
         </p:nvSpPr>
@@ -13411,7 +12964,7 @@
       </p:sp>
       <p:sp>
         <p:nvSpPr>
-          <p:cNvPr id="11" name="Shape 8"/>
+          <p:cNvPr id="10" name="Shape 7"/>
           <p:cNvSpPr/>
           <p:nvPr/>
         </p:nvSpPr>
@@ -13436,7 +12989,7 @@
       </p:sp>
       <p:sp>
         <p:nvSpPr>
-          <p:cNvPr id="12" name="Text 9"/>
+          <p:cNvPr id="11" name="Text 8"/>
           <p:cNvSpPr txBox="1"/>
           <p:nvPr/>
         </p:nvSpPr>
@@ -13475,7 +13028,7 @@
       </p:sp>
       <p:sp>
         <p:nvSpPr>
-          <p:cNvPr id="13" name="Shape 10"/>
+          <p:cNvPr id="12" name="Shape 9"/>
           <p:cNvSpPr/>
           <p:nvPr/>
         </p:nvSpPr>
@@ -13500,7 +13053,7 @@
       </p:sp>
       <p:sp>
         <p:nvSpPr>
-          <p:cNvPr id="14" name="Text 11"/>
+          <p:cNvPr id="13" name="Text 10"/>
           <p:cNvSpPr txBox="1"/>
           <p:nvPr/>
         </p:nvSpPr>
@@ -13539,7 +13092,7 @@
       </p:sp>
       <p:sp>
         <p:nvSpPr>
-          <p:cNvPr id="15" name="Shape 12"/>
+          <p:cNvPr id="14" name="Shape 11"/>
           <p:cNvSpPr/>
           <p:nvPr/>
         </p:nvSpPr>
@@ -13564,7 +13117,7 @@
       </p:sp>
       <p:sp>
         <p:nvSpPr>
-          <p:cNvPr id="16" name="Text 13"/>
+          <p:cNvPr id="15" name="Text 12"/>
           <p:cNvSpPr txBox="1"/>
           <p:nvPr/>
         </p:nvSpPr>
@@ -13603,7 +13156,7 @@
       </p:sp>
       <p:sp>
         <p:nvSpPr>
-          <p:cNvPr id="17" name="Text 14"/>
+          <p:cNvPr id="16" name="Text 13"/>
           <p:cNvSpPr txBox="1"/>
           <p:nvPr/>
         </p:nvSpPr>
@@ -13642,7 +13195,7 @@
       </p:sp>
       <p:sp>
         <p:nvSpPr>
-          <p:cNvPr id="18" name="Text 15"/>
+          <p:cNvPr id="17" name="Text 14"/>
           <p:cNvSpPr txBox="1"/>
           <p:nvPr/>
         </p:nvSpPr>
@@ -13681,7 +13234,7 @@
       </p:sp>
       <p:sp>
         <p:nvSpPr>
-          <p:cNvPr id="19" name="Shape 16"/>
+          <p:cNvPr id="18" name="Shape 15"/>
           <p:cNvSpPr/>
           <p:nvPr/>
         </p:nvSpPr>
@@ -13706,7 +13259,7 @@
       </p:sp>
       <p:sp>
         <p:nvSpPr>
-          <p:cNvPr id="20" name="Text 17"/>
+          <p:cNvPr id="19" name="Text 16"/>
           <p:cNvSpPr txBox="1"/>
           <p:nvPr/>
         </p:nvSpPr>
@@ -13745,7 +13298,7 @@
       </p:sp>
       <p:sp>
         <p:nvSpPr>
-          <p:cNvPr id="21" name="Shape 18"/>
+          <p:cNvPr id="20" name="Shape 17"/>
           <p:cNvSpPr/>
           <p:nvPr/>
         </p:nvSpPr>
@@ -13770,7 +13323,7 @@
       </p:sp>
       <p:sp>
         <p:nvSpPr>
-          <p:cNvPr id="22" name="Text 19"/>
+          <p:cNvPr id="21" name="Text 18"/>
           <p:cNvSpPr txBox="1"/>
           <p:nvPr/>
         </p:nvSpPr>
@@ -13809,7 +13362,7 @@
       </p:sp>
       <p:sp>
         <p:nvSpPr>
-          <p:cNvPr id="23" name="Shape 20"/>
+          <p:cNvPr id="22" name="Shape 19"/>
           <p:cNvSpPr/>
           <p:nvPr/>
         </p:nvSpPr>
@@ -13834,7 +13387,7 @@
       </p:sp>
       <p:sp>
         <p:nvSpPr>
-          <p:cNvPr id="24" name="Text 21"/>
+          <p:cNvPr id="23" name="Text 20"/>
           <p:cNvSpPr txBox="1"/>
           <p:nvPr/>
         </p:nvSpPr>
@@ -13873,7 +13426,7 @@
       </p:sp>
       <p:sp>
         <p:nvSpPr>
-          <p:cNvPr id="25" name="Shape 22"/>
+          <p:cNvPr id="24" name="Shape 21"/>
           <p:cNvSpPr/>
           <p:nvPr/>
         </p:nvSpPr>
@@ -13898,7 +13451,7 @@
       </p:sp>
       <p:sp>
         <p:nvSpPr>
-          <p:cNvPr id="26" name="Text 23"/>
+          <p:cNvPr id="25" name="Text 22"/>
           <p:cNvSpPr txBox="1"/>
           <p:nvPr/>
         </p:nvSpPr>
@@ -13937,7 +13490,7 @@
       </p:sp>
       <p:sp>
         <p:nvSpPr>
-          <p:cNvPr id="27" name="Shape 24"/>
+          <p:cNvPr id="26" name="Shape 23"/>
           <p:cNvSpPr/>
           <p:nvPr/>
         </p:nvSpPr>
@@ -13962,7 +13515,7 @@
       </p:sp>
       <p:sp>
         <p:nvSpPr>
-          <p:cNvPr id="28" name="Text 25"/>
+          <p:cNvPr id="27" name="Text 24"/>
           <p:cNvSpPr txBox="1"/>
           <p:nvPr/>
         </p:nvSpPr>
@@ -14021,7 +13574,7 @@
       </p:sp>
       <p:sp>
         <p:nvSpPr>
-          <p:cNvPr id="29" name="Text 26"/>
+          <p:cNvPr id="28" name="Text 25"/>
           <p:cNvSpPr txBox="1"/>
           <p:nvPr/>
         </p:nvSpPr>
@@ -14060,7 +13613,7 @@
       </p:sp>
       <p:sp>
         <p:nvSpPr>
-          <p:cNvPr id="30" name="Text 27"/>
+          <p:cNvPr id="29" name="Text 26"/>
           <p:cNvSpPr txBox="1"/>
           <p:nvPr/>
         </p:nvSpPr>

</xml_diff>

<commit_message>
Sunumun Türkçesini ekle, metni yerleşimden ayır
Türkçe sunum ayrı bir dosya olarak kopyalanmadı: yerleşim ortak kaldı,
metinler icerik.cjs içine taşındı ve dile göre ayrıldı — sitedeki
Record<Lang, ...> düzeniyle aynı mantık. Böylece bir yerleşim
düzeltmesi iki dile birden geçiyor. build.cjs ikisini de üretir,
"node build.cjs tr" yalnızca Türkçesini.

Türkçe metinler sitenin Türkçe metinlerinden gelir; İngilizcenin
çevirisi değildir. Bölüm görsellerinin de iki dili var: gorseller.cjs
artık '-en' ekli (İngilizce) ve eksiz (Türkçe) sürümleri birlikte
hazırlıyor.

Yol boyunca bulunan hata: QA render'ında kurulu fontlar yalnızca
'latin' alt kümesiydi, 'ğ İ ş' latin-ext'te olduğu için bu harfler
başka bir yüzden geliyordu — global.css'in tam olarak uyardığı durum.
Tam kapsamlı fontlarla yeniden render alındı; Türkçe metin artık
marka yüzüyle çıkıyor.

Co-Authored-By: Claude Opus 5 <noreply@anthropic.com>
Claude-Session: https://claude.ai/code/session_01WXCdRgW1YBZpNXmHm1YSp8
</commit_message>
<xml_diff>
--- a/sunum/CPeak-Consultancy-Company-Overview.pptx
+++ b/sunum/CPeak-Consultancy-Company-Overview.pptx
@@ -513,7 +513,7 @@
           <a:p>
             <a:r>
               <a:rPr lang="en-US" dirty="0"/>
-              <a:t>Kapak. Konumlandırma cümlesi sitenin H1 ve hero girişinden birebir. Görsel, sitenin kendi hero görselidir (public/media/hero-team.webp).</a:t>
+              <a:t>Kapak. Konumlandırma cümlesi sitenin H1 ve hero girişinden. Görsel sitenin kendi hero görselidir.</a:t>
             </a:r>
             <a:endParaRPr lang="en-US" dirty="0"/>
           </a:p>
@@ -601,7 +601,7 @@
           <a:p>
             <a:r>
               <a:rPr lang="en-US" dirty="0"/>
-              <a:t>Ana sayfadaki üç tipik proje, sitenin kendi uyarısıyla birlikte. Uydurma ölçüm, müşteri ya da sonuç yok.</a:t>
+              <a:t>Ana sayfadaki üç tipik proje, sitenin kendi uyarısıyla birlikte.</a:t>
             </a:r>
             <a:endParaRPr lang="en-US" dirty="0"/>
           </a:p>
@@ -689,7 +689,7 @@
           <a:p>
             <a:r>
               <a:rPr lang="en-US" dirty="0"/>
-              <a:t>Ana sayfadaki dört fark, özü değişmeden. Referans şeridi sitenin kendi logo bandıdır — destede hiçbir yerde iş ortaklığı, sertifika ya da ödül iddiası yok, çünkü sitede de yok.</a:t>
+              <a:t>Ana sayfadaki dört fark. Referans şeridi sitenin kendi logo bandıdır.</a:t>
             </a:r>
             <a:endParaRPr lang="en-US" dirty="0"/>
           </a:p>
@@ -777,7 +777,7 @@
           <a:p>
             <a:r>
               <a:rPr lang="en-US" dirty="0"/>
-              <a:t>Kapanış. Tüm iletişim bilgileri site yapılandırmasından: genel ve doğrudan adresler, telefon, kayıtlı ofis, web ve LinkedIn.</a:t>
+              <a:t>Kapanış. İletişim bilgileri site yapılandırmasından.</a:t>
             </a:r>
             <a:endParaRPr lang="en-US" dirty="0"/>
           </a:p>
@@ -865,7 +865,7 @@
           <a:p>
             <a:r>
               <a:rPr lang="en-US" dirty="0"/>
-              <a:t>Şirket tanıtımı. Buradaki her iddia Hakkımızda sayfasında var: bağımsızlık, finans odağı, lojistik kapsam için iş ortağı düzeni ve üç kurumsal bilgi. Koyu şerit sitenin kendi yetkinlik bandı — nitel, tek sayı 10+ yıl.</a:t>
+              <a:t>Şirket tanıtımı. Her iddia Hakkımızda sayfasında var. Koyu şerit sitenin yetkinlik bandı — nitel, tek sayı 10+ yıl.</a:t>
             </a:r>
             <a:endParaRPr lang="en-US" dirty="0"/>
           </a:p>
@@ -953,7 +953,7 @@
           <a:p>
             <a:r>
               <a:rPr lang="en-US" dirty="0"/>
-              <a:t>Hakkımızda sayfasındaki üç odak alanı, sitedeki sırayla. Görsel sitenin finans mimarisi şemasıdır.</a:t>
+              <a:t>Hakkımızda sayfasındaki üç odak alanı. Görsel sitenin finans mimarisi şemasıdır.</a:t>
             </a:r>
             <a:endParaRPr lang="en-US" dirty="0"/>
           </a:p>
@@ -1041,7 +1041,7 @@
           <a:p>
             <a:r>
               <a:rPr lang="en-US" dirty="0"/>
-              <a:t>SAP yetkinlik haritası. Dağıtım modelleri ve yapay zeka yetenekleri sitede geçenlerin aynısı; çekirdekteki maddeler Finans Modülleri sayfasındaki işi anlatır. Hiçbir yerde iş ortaklığı ya da sertifika iddiası yok.</a:t>
+              <a:t>SAP yetkinlik haritası. Dağıtım modelleri ve yapay zeka yetenekleri sitede geçenlerin aynısı. İş ortaklığı ya da sertifika iddiası yok.</a:t>
             </a:r>
             <a:endParaRPr lang="en-US" dirty="0"/>
           </a:p>
@@ -1129,7 +1129,7 @@
           <a:p>
             <a:r>
               <a:rPr lang="en-US" dirty="0"/>
-              <a:t>Beş çözüm sayfası, sitenin kendi ölçütleriyle karşılaştırıldı: kime uygun, tipik süre ve ana kazanım. Süreler her sayfanın comparison satırından alındı.</a:t>
+              <a:t>Beş çözüm sayfası, sitenin kendi ölçütleriyle: kime uygun, tipik süre, ana kazanım.</a:t>
             </a:r>
             <a:endParaRPr lang="en-US" dirty="0"/>
           </a:p>
@@ -1217,7 +1217,7 @@
           <a:p>
             <a:r>
               <a:rPr lang="en-US" dirty="0"/>
-              <a:t>Tarafsız karşılaştırma CPeak’in en net farkı. Ölçütler ve ifadeler Çözümler sayfasındaki karşılaştırma tablosundan kısaltıldı; görsel sitenin kendi bulut modelleri şeması.</a:t>
+              <a:t>Tarafsız karşılaştırma CPeak’in en net farkı. Ölçütler Çözümler sayfasındaki tablodan kısaltıldı.</a:t>
             </a:r>
             <a:endParaRPr lang="en-US" dirty="0"/>
           </a:p>
@@ -1305,7 +1305,7 @@
           <a:p>
             <a:r>
               <a:rPr lang="en-US" dirty="0"/>
-              <a:t>Yaklaşım sayfasındaki çalışma ilkeleri, anlattıkları değer zinciri olarak dizildi: ölç, karşılaştır, karar ver, sahiplen. Alttaki iki ilke zinciri ayakta tutan teslim disiplinidir.</a:t>
+              <a:t>Yaklaşım sayfasındaki çalışma ilkeleri, anlattıkları değer zinciri olarak dizildi.</a:t>
             </a:r>
             <a:endParaRPr lang="en-US" dirty="0"/>
           </a:p>
@@ -1393,7 +1393,7 @@
           <a:p>
             <a:r>
               <a:rPr lang="en-US" dirty="0"/>
-              <a:t>Ana sayfadaki dört aşamalı teslim modeli. Aşama adları ve çıktılar sitenin kendi süreç görselinde yazılı; slayt bunlara yalnızca süreleri ekler.</a:t>
+              <a:t>Dört aşamalı teslim modeli. Aşama adları ve çıktılar sitenin süreç görselinde yazılı; slayt yalnızca süreleri ekler.</a:t>
             </a:r>
             <a:endParaRPr lang="en-US" dirty="0"/>
           </a:p>
@@ -1481,7 +1481,7 @@
           <a:p>
             <a:r>
               <a:rPr lang="en-US" dirty="0"/>
-              <a:t>Ana sayfanın yapay zeka bölümü. Slaytın söylediği şu: her iki taraf da aynı SAP sisteminden ve aynı inceleme disiplininden geçiyor. Görsel sitenin kendi yapay zeka akış şeması.</a:t>
+              <a:t>Ana sayfanın yapay zeka bölümü. Görsel sitenin yapay zeka akış şemasıdır.</a:t>
             </a:r>
             <a:endParaRPr lang="en-US" dirty="0"/>
           </a:p>
@@ -1950,7 +1950,7 @@
         <p:spPr>
           <a:xfrm>
             <a:off x="777240" y="2871216"/>
-            <a:ext cx="4846320" cy="1828800"/>
+            <a:ext cx="4983480" cy="1828800"/>
           </a:xfrm>
           <a:prstGeom prst="rect">
             <a:avLst/>
@@ -1964,7 +1964,7 @@
           <a:p>
             <a:pPr indent="0" marL="0">
               <a:lnSpc>
-                <a:spcPts val="3800"/>
+                <a:spcPts val="3782"/>
               </a:lnSpc>
               <a:buNone/>
             </a:pPr>
@@ -1984,7 +1984,7 @@
           <a:p>
             <a:pPr indent="0" marL="0">
               <a:lnSpc>
-                <a:spcPts val="3800"/>
+                <a:spcPts val="3782"/>
               </a:lnSpc>
               <a:buNone/>
             </a:pPr>
@@ -2004,7 +2004,7 @@
           <a:p>
             <a:pPr indent="0" marL="0">
               <a:lnSpc>
-                <a:spcPts val="3800"/>
+                <a:spcPts val="3782"/>
               </a:lnSpc>
               <a:buNone/>
             </a:pPr>
@@ -2267,8 +2267,8 @@
         </p:nvSpPr>
         <p:spPr>
           <a:xfrm>
-            <a:off x="8122615" y="1412621"/>
-            <a:ext cx="3291840" cy="219456"/>
+            <a:off x="7573975" y="1412621"/>
+            <a:ext cx="3840480" cy="219456"/>
           </a:xfrm>
           <a:prstGeom prst="rect">
             <a:avLst/>
@@ -3686,7 +3686,7 @@
         <p:spPr>
           <a:xfrm>
             <a:off x="777240" y="3276854"/>
-            <a:ext cx="2395728" cy="1463040"/>
+            <a:ext cx="2395728" cy="1554480"/>
           </a:xfrm>
           <a:prstGeom prst="rect">
             <a:avLst/>
@@ -3809,7 +3809,7 @@
         <p:spPr>
           <a:xfrm>
             <a:off x="3483864" y="3276854"/>
-            <a:ext cx="2395728" cy="1463040"/>
+            <a:ext cx="2395728" cy="1554480"/>
           </a:xfrm>
           <a:prstGeom prst="rect">
             <a:avLst/>
@@ -3932,7 +3932,7 @@
         <p:spPr>
           <a:xfrm>
             <a:off x="6190488" y="3276854"/>
-            <a:ext cx="2395728" cy="1463040"/>
+            <a:ext cx="2395728" cy="1554480"/>
           </a:xfrm>
           <a:prstGeom prst="rect">
             <a:avLst/>
@@ -4055,7 +4055,7 @@
         <p:spPr>
           <a:xfrm>
             <a:off x="8897112" y="3276854"/>
-            <a:ext cx="2395728" cy="1463040"/>
+            <a:ext cx="2395728" cy="1554480"/>
           </a:xfrm>
           <a:prstGeom prst="rect">
             <a:avLst/>
@@ -4117,7 +4117,7 @@
         <p:spPr>
           <a:xfrm>
             <a:off x="777240" y="5532120"/>
-            <a:ext cx="1280160" cy="182880"/>
+            <a:ext cx="1371600" cy="182880"/>
           </a:xfrm>
           <a:prstGeom prst="rect">
             <a:avLst/>
@@ -4163,7 +4163,7 @@
         </p:blipFill>
         <p:spPr>
           <a:xfrm>
-            <a:off x="2388034" y="5498705"/>
+            <a:off x="2420038" y="5498705"/>
             <a:ext cx="987552" cy="249710"/>
           </a:xfrm>
           <a:prstGeom prst="rect">
@@ -4187,7 +4187,7 @@
         </p:blipFill>
         <p:spPr>
           <a:xfrm>
-            <a:off x="3686482" y="5486400"/>
+            <a:off x="3718486" y="5486400"/>
             <a:ext cx="564776" cy="274320"/>
           </a:xfrm>
           <a:prstGeom prst="rect">
@@ -4211,7 +4211,7 @@
         </p:blipFill>
         <p:spPr>
           <a:xfrm>
-            <a:off x="4562155" y="5486400"/>
+            <a:off x="4594159" y="5486400"/>
             <a:ext cx="624314" cy="274320"/>
           </a:xfrm>
           <a:prstGeom prst="rect">
@@ -4235,7 +4235,7 @@
         </p:blipFill>
         <p:spPr>
           <a:xfrm>
-            <a:off x="5497365" y="5486400"/>
+            <a:off x="5529369" y="5486400"/>
             <a:ext cx="888492" cy="274320"/>
           </a:xfrm>
           <a:prstGeom prst="rect">
@@ -4259,7 +4259,7 @@
         </p:blipFill>
         <p:spPr>
           <a:xfrm>
-            <a:off x="6696753" y="5505608"/>
+            <a:off x="6728757" y="5505608"/>
             <a:ext cx="974385" cy="235904"/>
           </a:xfrm>
           <a:prstGeom prst="rect">
@@ -4283,7 +4283,7 @@
         </p:blipFill>
         <p:spPr>
           <a:xfrm>
-            <a:off x="7982034" y="5486400"/>
+            <a:off x="8014038" y="5486400"/>
             <a:ext cx="426720" cy="274320"/>
           </a:xfrm>
           <a:prstGeom prst="rect">
@@ -4307,7 +4307,7 @@
         </p:blipFill>
         <p:spPr>
           <a:xfrm>
-            <a:off x="8719650" y="5486400"/>
+            <a:off x="8751654" y="5486400"/>
             <a:ext cx="868887" cy="274320"/>
           </a:xfrm>
           <a:prstGeom prst="rect">
@@ -4331,7 +4331,7 @@
         </p:blipFill>
         <p:spPr>
           <a:xfrm>
-            <a:off x="9899433" y="5486400"/>
+            <a:off x="9931437" y="5486400"/>
             <a:ext cx="481263" cy="274320"/>
           </a:xfrm>
           <a:prstGeom prst="rect">
@@ -4355,7 +4355,7 @@
         </p:blipFill>
         <p:spPr>
           <a:xfrm>
-            <a:off x="10691592" y="5486400"/>
+            <a:off x="10723596" y="5486400"/>
             <a:ext cx="529389" cy="274320"/>
           </a:xfrm>
           <a:prstGeom prst="rect">
@@ -4583,7 +4583,7 @@
           <a:p>
             <a:pPr indent="0" marL="0">
               <a:lnSpc>
-                <a:spcPts val="3600"/>
+                <a:spcPts val="3612"/>
               </a:lnSpc>
               <a:buNone/>
             </a:pPr>
@@ -4603,7 +4603,7 @@
           <a:p>
             <a:pPr indent="0" marL="0">
               <a:lnSpc>
-                <a:spcPts val="3600"/>
+                <a:spcPts val="3612"/>
               </a:lnSpc>
               <a:buNone/>
             </a:pPr>
@@ -4623,7 +4623,7 @@
           <a:p>
             <a:pPr indent="0" marL="0">
               <a:lnSpc>
-                <a:spcPts val="3600"/>
+                <a:spcPts val="3612"/>
               </a:lnSpc>
               <a:buNone/>
             </a:pPr>
@@ -4651,7 +4651,7 @@
         <p:spPr>
           <a:xfrm>
             <a:off x="777240" y="4261104"/>
-            <a:ext cx="5120640" cy="457200"/>
+            <a:ext cx="5120640" cy="548640"/>
           </a:xfrm>
           <a:prstGeom prst="rect">
             <a:avLst/>
@@ -5217,7 +5217,7 @@
             <a:r>
               <a:rPr lang="en-US" sz="750" spc="60" kern="0" dirty="0">
                 <a:solidFill>
-                  <a:srgbClr val="8CA9C7"/>
+                  <a:srgbClr val="809FC1"/>
                 </a:solidFill>
                 <a:latin typeface="IBM Plex Mono" pitchFamily="34" charset="0"/>
                 <a:ea typeface="IBM Plex Mono" pitchFamily="34" charset="-122"/>
@@ -5351,7 +5351,7 @@
         <p:spPr>
           <a:xfrm>
             <a:off x="6400800" y="804672"/>
-            <a:ext cx="5010912" cy="1005840"/>
+            <a:ext cx="5010912" cy="1051560"/>
           </a:xfrm>
           <a:prstGeom prst="rect">
             <a:avLst/>
@@ -5393,7 +5393,7 @@
         <p:spPr>
           <a:xfrm>
             <a:off x="6400800" y="2103120"/>
-            <a:ext cx="5010912" cy="1005840"/>
+            <a:ext cx="5010912" cy="1051560"/>
           </a:xfrm>
           <a:prstGeom prst="rect">
             <a:avLst/>
@@ -5435,7 +5435,7 @@
         <p:spPr>
           <a:xfrm>
             <a:off x="6400800" y="3401568"/>
-            <a:ext cx="5010912" cy="1005840"/>
+            <a:ext cx="5010912" cy="1051560"/>
           </a:xfrm>
           <a:prstGeom prst="rect">
             <a:avLst/>
@@ -6362,7 +6362,7 @@
         <p:spPr>
           <a:xfrm>
             <a:off x="1307592" y="2724912"/>
-            <a:ext cx="4315968" cy="731520"/>
+            <a:ext cx="4315968" cy="777240"/>
           </a:xfrm>
           <a:prstGeom prst="rect">
             <a:avLst/>
@@ -6482,7 +6482,7 @@
         <p:spPr>
           <a:xfrm>
             <a:off x="1307592" y="3895344"/>
-            <a:ext cx="4315968" cy="731520"/>
+            <a:ext cx="4315968" cy="777240"/>
           </a:xfrm>
           <a:prstGeom prst="rect">
             <a:avLst/>
@@ -6602,7 +6602,7 @@
         <p:spPr>
           <a:xfrm>
             <a:off x="1307592" y="5065776"/>
-            <a:ext cx="4315968" cy="731520"/>
+            <a:ext cx="4315968" cy="777240"/>
           </a:xfrm>
           <a:prstGeom prst="rect">
             <a:avLst/>
@@ -6972,7 +6972,7 @@
         <p:spPr>
           <a:xfrm>
             <a:off x="923544" y="2404872"/>
-            <a:ext cx="2229536" cy="274320"/>
+            <a:ext cx="2229536" cy="292608"/>
           </a:xfrm>
           <a:prstGeom prst="rect">
             <a:avLst/>
@@ -7073,7 +7073,7 @@
         <p:spPr>
           <a:xfrm>
             <a:off x="923544" y="3186684"/>
-            <a:ext cx="2229536" cy="274320"/>
+            <a:ext cx="2229536" cy="292608"/>
           </a:xfrm>
           <a:prstGeom prst="rect">
             <a:avLst/>
@@ -7174,7 +7174,7 @@
         <p:spPr>
           <a:xfrm>
             <a:off x="923544" y="3968496"/>
-            <a:ext cx="2229536" cy="274320"/>
+            <a:ext cx="2229536" cy="292608"/>
           </a:xfrm>
           <a:prstGeom prst="rect">
             <a:avLst/>
@@ -7275,7 +7275,7 @@
         <p:spPr>
           <a:xfrm>
             <a:off x="923544" y="4750308"/>
-            <a:ext cx="2229536" cy="274320"/>
+            <a:ext cx="2229536" cy="292608"/>
           </a:xfrm>
           <a:prstGeom prst="rect">
             <a:avLst/>
@@ -7376,7 +7376,7 @@
         <p:spPr>
           <a:xfrm>
             <a:off x="9038615" y="2404872"/>
-            <a:ext cx="2229536" cy="274320"/>
+            <a:ext cx="2229536" cy="292608"/>
           </a:xfrm>
           <a:prstGeom prst="rect">
             <a:avLst/>
@@ -7477,7 +7477,7 @@
         <p:spPr>
           <a:xfrm>
             <a:off x="9038615" y="3186684"/>
-            <a:ext cx="2229536" cy="274320"/>
+            <a:ext cx="2229536" cy="292608"/>
           </a:xfrm>
           <a:prstGeom prst="rect">
             <a:avLst/>
@@ -7578,7 +7578,7 @@
         <p:spPr>
           <a:xfrm>
             <a:off x="9038615" y="3968496"/>
-            <a:ext cx="2229536" cy="274320"/>
+            <a:ext cx="2229536" cy="292608"/>
           </a:xfrm>
           <a:prstGeom prst="rect">
             <a:avLst/>
@@ -7679,7 +7679,7 @@
         <p:spPr>
           <a:xfrm>
             <a:off x="9038615" y="4750308"/>
-            <a:ext cx="2229536" cy="274320"/>
+            <a:ext cx="2229536" cy="292608"/>
           </a:xfrm>
           <a:prstGeom prst="rect">
             <a:avLst/>
@@ -8607,7 +8607,7 @@
         <p:spPr>
           <a:xfrm>
             <a:off x="3840480" y="2612644"/>
-            <a:ext cx="2788920" cy="548640"/>
+            <a:ext cx="2788920" cy="603504"/>
           </a:xfrm>
           <a:prstGeom prst="rect">
             <a:avLst/>
@@ -8711,7 +8711,7 @@
         <p:spPr>
           <a:xfrm>
             <a:off x="8961120" y="2612644"/>
-            <a:ext cx="2450592" cy="548640"/>
+            <a:ext cx="2450592" cy="603504"/>
           </a:xfrm>
           <a:prstGeom prst="rect">
             <a:avLst/>
@@ -8834,7 +8834,7 @@
         <p:spPr>
           <a:xfrm>
             <a:off x="3840480" y="3362452"/>
-            <a:ext cx="2788920" cy="548640"/>
+            <a:ext cx="2788920" cy="603504"/>
           </a:xfrm>
           <a:prstGeom prst="rect">
             <a:avLst/>
@@ -8938,7 +8938,7 @@
         <p:spPr>
           <a:xfrm>
             <a:off x="8961120" y="3362452"/>
-            <a:ext cx="2450592" cy="548640"/>
+            <a:ext cx="2450592" cy="603504"/>
           </a:xfrm>
           <a:prstGeom prst="rect">
             <a:avLst/>
@@ -9061,7 +9061,7 @@
         <p:spPr>
           <a:xfrm>
             <a:off x="3840480" y="4112260"/>
-            <a:ext cx="2788920" cy="548640"/>
+            <a:ext cx="2788920" cy="603504"/>
           </a:xfrm>
           <a:prstGeom prst="rect">
             <a:avLst/>
@@ -9165,7 +9165,7 @@
         <p:spPr>
           <a:xfrm>
             <a:off x="8961120" y="4112260"/>
-            <a:ext cx="2450592" cy="548640"/>
+            <a:ext cx="2450592" cy="603504"/>
           </a:xfrm>
           <a:prstGeom prst="rect">
             <a:avLst/>
@@ -9288,7 +9288,7 @@
         <p:spPr>
           <a:xfrm>
             <a:off x="3840480" y="4862068"/>
-            <a:ext cx="2788920" cy="548640"/>
+            <a:ext cx="2788920" cy="603504"/>
           </a:xfrm>
           <a:prstGeom prst="rect">
             <a:avLst/>
@@ -9392,7 +9392,7 @@
         <p:spPr>
           <a:xfrm>
             <a:off x="8961120" y="4862068"/>
-            <a:ext cx="2450592" cy="548640"/>
+            <a:ext cx="2450592" cy="603504"/>
           </a:xfrm>
           <a:prstGeom prst="rect">
             <a:avLst/>
@@ -9515,7 +9515,7 @@
         <p:spPr>
           <a:xfrm>
             <a:off x="3840480" y="5611876"/>
-            <a:ext cx="2788920" cy="548640"/>
+            <a:ext cx="2788920" cy="603504"/>
           </a:xfrm>
           <a:prstGeom prst="rect">
             <a:avLst/>
@@ -9619,7 +9619,7 @@
         <p:spPr>
           <a:xfrm>
             <a:off x="8961120" y="5611876"/>
-            <a:ext cx="2450592" cy="548640"/>
+            <a:ext cx="2450592" cy="603504"/>
           </a:xfrm>
           <a:prstGeom prst="rect">
             <a:avLst/>
@@ -11244,7 +11244,7 @@
         <p:spPr>
           <a:xfrm>
             <a:off x="777240" y="3521329"/>
-            <a:ext cx="2395728" cy="1097280"/>
+            <a:ext cx="2395728" cy="1188720"/>
           </a:xfrm>
           <a:prstGeom prst="rect">
             <a:avLst/>
@@ -11364,7 +11364,7 @@
         <p:spPr>
           <a:xfrm>
             <a:off x="3483864" y="3521329"/>
-            <a:ext cx="2395728" cy="1097280"/>
+            <a:ext cx="2395728" cy="1188720"/>
           </a:xfrm>
           <a:prstGeom prst="rect">
             <a:avLst/>
@@ -11484,7 +11484,7 @@
         <p:spPr>
           <a:xfrm>
             <a:off x="6190488" y="3521329"/>
-            <a:ext cx="2395728" cy="1097280"/>
+            <a:ext cx="2395728" cy="1188720"/>
           </a:xfrm>
           <a:prstGeom prst="rect">
             <a:avLst/>
@@ -11604,7 +11604,7 @@
         <p:spPr>
           <a:xfrm>
             <a:off x="8897112" y="3521329"/>
-            <a:ext cx="2395728" cy="1097280"/>
+            <a:ext cx="2395728" cy="1188720"/>
           </a:xfrm>
           <a:prstGeom prst="rect">
             <a:avLst/>
@@ -12143,7 +12143,7 @@
         <p:spPr>
           <a:xfrm>
             <a:off x="1280160" y="3163824"/>
-            <a:ext cx="2194560" cy="237744"/>
+            <a:ext cx="2286000" cy="237744"/>
           </a:xfrm>
           <a:prstGeom prst="rect">
             <a:avLst/>
@@ -12181,8 +12181,8 @@
         </p:nvSpPr>
         <p:spPr>
           <a:xfrm>
-            <a:off x="3474720" y="3163824"/>
-            <a:ext cx="1280160" cy="237744"/>
+            <a:off x="3566160" y="3163824"/>
+            <a:ext cx="1188720" cy="237744"/>
           </a:xfrm>
           <a:prstGeom prst="rect">
             <a:avLst/>
@@ -12260,7 +12260,7 @@
         <p:spPr>
           <a:xfrm>
             <a:off x="1280160" y="3666744"/>
-            <a:ext cx="2194560" cy="237744"/>
+            <a:ext cx="2286000" cy="237744"/>
           </a:xfrm>
           <a:prstGeom prst="rect">
             <a:avLst/>
@@ -12298,8 +12298,8 @@
         </p:nvSpPr>
         <p:spPr>
           <a:xfrm>
-            <a:off x="3474720" y="3666744"/>
-            <a:ext cx="1280160" cy="237744"/>
+            <a:off x="3566160" y="3666744"/>
+            <a:ext cx="1188720" cy="237744"/>
           </a:xfrm>
           <a:prstGeom prst="rect">
             <a:avLst/>
@@ -12377,7 +12377,7 @@
         <p:spPr>
           <a:xfrm>
             <a:off x="1280160" y="4169664"/>
-            <a:ext cx="2194560" cy="237744"/>
+            <a:ext cx="2286000" cy="237744"/>
           </a:xfrm>
           <a:prstGeom prst="rect">
             <a:avLst/>
@@ -12415,8 +12415,8 @@
         </p:nvSpPr>
         <p:spPr>
           <a:xfrm>
-            <a:off x="3474720" y="4169664"/>
-            <a:ext cx="1280160" cy="237744"/>
+            <a:off x="3566160" y="4169664"/>
+            <a:ext cx="1188720" cy="237744"/>
           </a:xfrm>
           <a:prstGeom prst="rect">
             <a:avLst/>
@@ -12494,7 +12494,7 @@
         <p:spPr>
           <a:xfrm>
             <a:off x="1280160" y="4672584"/>
-            <a:ext cx="2194560" cy="237744"/>
+            <a:ext cx="2286000" cy="237744"/>
           </a:xfrm>
           <a:prstGeom prst="rect">
             <a:avLst/>
@@ -12532,8 +12532,8 @@
         </p:nvSpPr>
         <p:spPr>
           <a:xfrm>
-            <a:off x="3474720" y="4672584"/>
-            <a:ext cx="1280160" cy="237744"/>
+            <a:off x="3566160" y="4672584"/>
+            <a:ext cx="1188720" cy="237744"/>
           </a:xfrm>
           <a:prstGeom prst="rect">
             <a:avLst/>

</xml_diff>